<commit_message>
Make worker transform PPT templates with LLM
</commit_message>
<xml_diff>
--- a/sample_uploads/template.pptx
+++ b/sample_uploads/template.pptx
@@ -7,7 +7,7 @@
   <p:sldIdLst>
     <p:sldId id="256" r:id="rId7"/>
   </p:sldIdLst>
-  <p:sldSz cx="9144000" cy="6858000" type="screen4x3"/>
+  <p:sldSz cx="12191695" cy="6858000" type="screen4x3"/>
   <p:notesSz cx="6858000" cy="9144000"/>
   <p:defaultTextStyle>
     <a:defPPr>
@@ -3081,6 +3081,14 @@
 <file path=ppt/slides/slide1.xml><?xml version="1.0" encoding="utf-8"?>
 <p:sld xmlns:a="http://schemas.openxmlformats.org/drawingml/2006/main" xmlns:p="http://schemas.openxmlformats.org/presentationml/2006/main" xmlns:r="http://schemas.openxmlformats.org/officeDocument/2006/relationships">
   <p:cSld>
+    <p:bg>
+      <p:bgPr>
+        <a:solidFill>
+          <a:srgbClr val="F6F8FB"/>
+        </a:solidFill>
+        <a:effectLst/>
+      </p:bgPr>
+    </p:bg>
     <p:spTree>
       <p:nvGrpSpPr>
         <p:cNvPr id="1" name=""/>
@@ -3090,42 +3098,542 @@
       <p:grpSpPr/>
       <p:sp>
         <p:nvSpPr>
-          <p:cNvPr id="2" name="Title 1"/>
-          <p:cNvSpPr>
-            <a:spLocks noGrp="1"/>
-          </p:cNvSpPr>
-          <p:nvPr>
-            <p:ph type="ctrTitle"/>
-          </p:nvPr>
-        </p:nvSpPr>
-        <p:spPr/>
-        <p:txBody>
-          <a:bodyPr/>
-          <a:lstStyle/>
-          <a:p>
-            <a:r>
-              <a:t>Prompt-to-PPT Demo Template</a:t>
-            </a:r>
-          </a:p>
-        </p:txBody>
-      </p:sp>
-      <p:sp>
-        <p:nvSpPr>
-          <p:cNvPr id="3" name="Subtitle 2"/>
-          <p:cNvSpPr>
-            <a:spLocks noGrp="1"/>
-          </p:cNvSpPr>
-          <p:nvPr>
-            <p:ph type="subTitle" idx="1"/>
-          </p:nvPr>
-        </p:nvSpPr>
-        <p:spPr/>
-        <p:txBody>
-          <a:bodyPr/>
-          <a:lstStyle/>
-          <a:p>
-            <a:r>
-              <a:t>Enterprise layout placeholder</a:t>
+          <p:cNvPr id="2" name="Rectangle 1"/>
+          <p:cNvSpPr/>
+          <p:nvPr/>
+        </p:nvSpPr>
+        <p:spPr>
+          <a:xfrm>
+            <a:off x="0" y="0"/>
+            <a:ext cx="12191695" cy="164592"/>
+          </a:xfrm>
+          <a:prstGeom prst="rect">
+            <a:avLst/>
+          </a:prstGeom>
+          <a:solidFill>
+            <a:srgbClr val="014986"/>
+          </a:solidFill>
+          <a:ln>
+            <a:noFill/>
+          </a:ln>
+        </p:spPr>
+        <p:style>
+          <a:lnRef idx="1">
+            <a:schemeClr val="accent1"/>
+          </a:lnRef>
+          <a:fillRef idx="3">
+            <a:schemeClr val="accent1"/>
+          </a:fillRef>
+          <a:effectRef idx="2">
+            <a:schemeClr val="accent1"/>
+          </a:effectRef>
+          <a:fontRef idx="minor">
+            <a:schemeClr val="lt1"/>
+          </a:fontRef>
+        </p:style>
+        <p:txBody>
+          <a:bodyPr rtlCol="0" anchor="ctr"/>
+          <a:lstStyle/>
+          <a:p>
+            <a:pPr algn="ctr"/>
+          </a:p>
+        </p:txBody>
+      </p:sp>
+      <p:sp>
+        <p:nvSpPr>
+          <p:cNvPr id="3" name="Rectangle 2"/>
+          <p:cNvSpPr/>
+          <p:nvPr/>
+        </p:nvSpPr>
+        <p:spPr>
+          <a:xfrm>
+            <a:off x="0" y="0"/>
+            <a:ext cx="320040" cy="6858000"/>
+          </a:xfrm>
+          <a:prstGeom prst="rect">
+            <a:avLst/>
+          </a:prstGeom>
+          <a:solidFill>
+            <a:srgbClr val="001F3F"/>
+          </a:solidFill>
+          <a:ln>
+            <a:noFill/>
+          </a:ln>
+        </p:spPr>
+        <p:style>
+          <a:lnRef idx="1">
+            <a:schemeClr val="accent1"/>
+          </a:lnRef>
+          <a:fillRef idx="3">
+            <a:schemeClr val="accent1"/>
+          </a:fillRef>
+          <a:effectRef idx="2">
+            <a:schemeClr val="accent1"/>
+          </a:effectRef>
+          <a:fontRef idx="minor">
+            <a:schemeClr val="lt1"/>
+          </a:fontRef>
+        </p:style>
+        <p:txBody>
+          <a:bodyPr rtlCol="0" anchor="ctr"/>
+          <a:lstStyle/>
+          <a:p>
+            <a:pPr algn="ctr"/>
+          </a:p>
+        </p:txBody>
+      </p:sp>
+      <p:sp>
+        <p:nvSpPr>
+          <p:cNvPr id="4" name="Rectangle 3"/>
+          <p:cNvSpPr/>
+          <p:nvPr/>
+        </p:nvSpPr>
+        <p:spPr>
+          <a:xfrm>
+            <a:off x="822960" y="914400"/>
+            <a:ext cx="4846320" cy="1417320"/>
+          </a:xfrm>
+          <a:prstGeom prst="rect">
+            <a:avLst/>
+          </a:prstGeom>
+          <a:solidFill>
+            <a:srgbClr val="FFFFFF"/>
+          </a:solidFill>
+          <a:ln>
+            <a:solidFill>
+              <a:srgbClr val="E2E8F0"/>
+            </a:solidFill>
+          </a:ln>
+        </p:spPr>
+        <p:style>
+          <a:lnRef idx="1">
+            <a:schemeClr val="accent1"/>
+          </a:lnRef>
+          <a:fillRef idx="3">
+            <a:schemeClr val="accent1"/>
+          </a:fillRef>
+          <a:effectRef idx="2">
+            <a:schemeClr val="accent1"/>
+          </a:effectRef>
+          <a:fontRef idx="minor">
+            <a:schemeClr val="lt1"/>
+          </a:fontRef>
+        </p:style>
+        <p:txBody>
+          <a:bodyPr rtlCol="0" anchor="ctr"/>
+          <a:lstStyle/>
+          <a:p>
+            <a:pPr>
+              <a:defRPr sz="2600" b="1">
+                <a:solidFill>
+                  <a:srgbClr val="001F3F"/>
+                </a:solidFill>
+                <a:latin typeface="Aptos Display"/>
+              </a:defRPr>
+            </a:pPr>
+            <a:r>
+              <a:t>Prompt-to-PPT</a:t>
+            </a:r>
+          </a:p>
+          <a:p>
+            <a:pPr>
+              <a:defRPr sz="1600" b="0">
+                <a:solidFill>
+                  <a:srgbClr val="475569"/>
+                </a:solidFill>
+                <a:latin typeface="Aptos Display"/>
+              </a:defRPr>
+            </a:pPr>
+            <a:r>
+              <a:t>Corporate Review Template</a:t>
+            </a:r>
+          </a:p>
+        </p:txBody>
+      </p:sp>
+      <p:sp>
+        <p:nvSpPr>
+          <p:cNvPr id="5" name="TextBox 4"/>
+          <p:cNvSpPr txBox="1"/>
+          <p:nvPr/>
+        </p:nvSpPr>
+        <p:spPr>
+          <a:xfrm>
+            <a:off x="822960" y="2606040"/>
+            <a:ext cx="6400800" cy="548640"/>
+          </a:xfrm>
+          <a:prstGeom prst="rect">
+            <a:avLst/>
+          </a:prstGeom>
+          <a:noFill/>
+        </p:spPr>
+        <p:txBody>
+          <a:bodyPr wrap="none">
+            <a:spAutoFit/>
+          </a:bodyPr>
+          <a:lstStyle/>
+          <a:p>
+            <a:pPr>
+              <a:defRPr sz="1500">
+                <a:solidFill>
+                  <a:srgbClr val="475569"/>
+                </a:solidFill>
+                <a:latin typeface="Aptos"/>
+              </a:defRPr>
+            </a:pPr>
+            <a:r>
+              <a:t>Use this file as the template input. Generated slides will inherit this navy, teal, and gold business-review style.</a:t>
+            </a:r>
+          </a:p>
+        </p:txBody>
+      </p:sp>
+      <p:sp>
+        <p:nvSpPr>
+          <p:cNvPr id="6" name="Rectangle 5"/>
+          <p:cNvSpPr/>
+          <p:nvPr/>
+        </p:nvSpPr>
+        <p:spPr>
+          <a:xfrm>
+            <a:off x="822960" y="3840480"/>
+            <a:ext cx="1005840" cy="502920"/>
+          </a:xfrm>
+          <a:prstGeom prst="rect">
+            <a:avLst/>
+          </a:prstGeom>
+          <a:solidFill>
+            <a:srgbClr val="001F3F"/>
+          </a:solidFill>
+          <a:ln>
+            <a:noFill/>
+          </a:ln>
+        </p:spPr>
+        <p:style>
+          <a:lnRef idx="1">
+            <a:schemeClr val="accent1"/>
+          </a:lnRef>
+          <a:fillRef idx="3">
+            <a:schemeClr val="accent1"/>
+          </a:fillRef>
+          <a:effectRef idx="2">
+            <a:schemeClr val="accent1"/>
+          </a:effectRef>
+          <a:fontRef idx="minor">
+            <a:schemeClr val="lt1"/>
+          </a:fontRef>
+        </p:style>
+        <p:txBody>
+          <a:bodyPr rtlCol="0" anchor="ctr"/>
+          <a:lstStyle/>
+          <a:p>
+            <a:pPr algn="ctr"/>
+          </a:p>
+        </p:txBody>
+      </p:sp>
+      <p:sp>
+        <p:nvSpPr>
+          <p:cNvPr id="7" name="TextBox 6"/>
+          <p:cNvSpPr txBox="1"/>
+          <p:nvPr/>
+        </p:nvSpPr>
+        <p:spPr>
+          <a:xfrm>
+            <a:off x="822960" y="4434840"/>
+            <a:ext cx="1097280" cy="411480"/>
+          </a:xfrm>
+          <a:prstGeom prst="rect">
+            <a:avLst/>
+          </a:prstGeom>
+          <a:noFill/>
+        </p:spPr>
+        <p:txBody>
+          <a:bodyPr wrap="none">
+            <a:spAutoFit/>
+          </a:bodyPr>
+          <a:lstStyle/>
+          <a:p>
+            <a:pPr>
+              <a:defRPr sz="1000">
+                <a:solidFill>
+                  <a:srgbClr val="475569"/>
+                </a:solidFill>
+                <a:latin typeface="Aptos"/>
+              </a:defRPr>
+            </a:pPr>
+            <a:r>
+              <a:t>Primary</a:t>
+            </a:r>
+          </a:p>
+        </p:txBody>
+      </p:sp>
+      <p:sp>
+        <p:nvSpPr>
+          <p:cNvPr id="8" name="Rectangle 7"/>
+          <p:cNvSpPr/>
+          <p:nvPr/>
+        </p:nvSpPr>
+        <p:spPr>
+          <a:xfrm>
+            <a:off x="2240280" y="3840480"/>
+            <a:ext cx="1005840" cy="502920"/>
+          </a:xfrm>
+          <a:prstGeom prst="rect">
+            <a:avLst/>
+          </a:prstGeom>
+          <a:solidFill>
+            <a:srgbClr val="014986"/>
+          </a:solidFill>
+          <a:ln>
+            <a:noFill/>
+          </a:ln>
+        </p:spPr>
+        <p:style>
+          <a:lnRef idx="1">
+            <a:schemeClr val="accent1"/>
+          </a:lnRef>
+          <a:fillRef idx="3">
+            <a:schemeClr val="accent1"/>
+          </a:fillRef>
+          <a:effectRef idx="2">
+            <a:schemeClr val="accent1"/>
+          </a:effectRef>
+          <a:fontRef idx="minor">
+            <a:schemeClr val="lt1"/>
+          </a:fontRef>
+        </p:style>
+        <p:txBody>
+          <a:bodyPr rtlCol="0" anchor="ctr"/>
+          <a:lstStyle/>
+          <a:p>
+            <a:pPr algn="ctr"/>
+          </a:p>
+        </p:txBody>
+      </p:sp>
+      <p:sp>
+        <p:nvSpPr>
+          <p:cNvPr id="9" name="TextBox 8"/>
+          <p:cNvSpPr txBox="1"/>
+          <p:nvPr/>
+        </p:nvSpPr>
+        <p:spPr>
+          <a:xfrm>
+            <a:off x="2240280" y="4434840"/>
+            <a:ext cx="1097280" cy="411480"/>
+          </a:xfrm>
+          <a:prstGeom prst="rect">
+            <a:avLst/>
+          </a:prstGeom>
+          <a:noFill/>
+        </p:spPr>
+        <p:txBody>
+          <a:bodyPr wrap="none">
+            <a:spAutoFit/>
+          </a:bodyPr>
+          <a:lstStyle/>
+          <a:p>
+            <a:pPr>
+              <a:defRPr sz="1000">
+                <a:solidFill>
+                  <a:srgbClr val="475569"/>
+                </a:solidFill>
+                <a:latin typeface="Aptos"/>
+              </a:defRPr>
+            </a:pPr>
+            <a:r>
+              <a:t>Accent</a:t>
+            </a:r>
+          </a:p>
+        </p:txBody>
+      </p:sp>
+      <p:sp>
+        <p:nvSpPr>
+          <p:cNvPr id="10" name="Rectangle 9"/>
+          <p:cNvSpPr/>
+          <p:nvPr/>
+        </p:nvSpPr>
+        <p:spPr>
+          <a:xfrm>
+            <a:off x="3657600" y="3840480"/>
+            <a:ext cx="1005840" cy="502920"/>
+          </a:xfrm>
+          <a:prstGeom prst="rect">
+            <a:avLst/>
+          </a:prstGeom>
+          <a:solidFill>
+            <a:srgbClr val="149496"/>
+          </a:solidFill>
+          <a:ln>
+            <a:noFill/>
+          </a:ln>
+        </p:spPr>
+        <p:style>
+          <a:lnRef idx="1">
+            <a:schemeClr val="accent1"/>
+          </a:lnRef>
+          <a:fillRef idx="3">
+            <a:schemeClr val="accent1"/>
+          </a:fillRef>
+          <a:effectRef idx="2">
+            <a:schemeClr val="accent1"/>
+          </a:effectRef>
+          <a:fontRef idx="minor">
+            <a:schemeClr val="lt1"/>
+          </a:fontRef>
+        </p:style>
+        <p:txBody>
+          <a:bodyPr rtlCol="0" anchor="ctr"/>
+          <a:lstStyle/>
+          <a:p>
+            <a:pPr algn="ctr"/>
+          </a:p>
+        </p:txBody>
+      </p:sp>
+      <p:sp>
+        <p:nvSpPr>
+          <p:cNvPr id="11" name="TextBox 10"/>
+          <p:cNvSpPr txBox="1"/>
+          <p:nvPr/>
+        </p:nvSpPr>
+        <p:spPr>
+          <a:xfrm>
+            <a:off x="3657600" y="4434840"/>
+            <a:ext cx="1097280" cy="411480"/>
+          </a:xfrm>
+          <a:prstGeom prst="rect">
+            <a:avLst/>
+          </a:prstGeom>
+          <a:noFill/>
+        </p:spPr>
+        <p:txBody>
+          <a:bodyPr wrap="none">
+            <a:spAutoFit/>
+          </a:bodyPr>
+          <a:lstStyle/>
+          <a:p>
+            <a:pPr>
+              <a:defRPr sz="1000">
+                <a:solidFill>
+                  <a:srgbClr val="475569"/>
+                </a:solidFill>
+                <a:latin typeface="Aptos"/>
+              </a:defRPr>
+            </a:pPr>
+            <a:r>
+              <a:t>Signal</a:t>
+            </a:r>
+          </a:p>
+        </p:txBody>
+      </p:sp>
+      <p:sp>
+        <p:nvSpPr>
+          <p:cNvPr id="12" name="Rectangle 11"/>
+          <p:cNvSpPr/>
+          <p:nvPr/>
+        </p:nvSpPr>
+        <p:spPr>
+          <a:xfrm>
+            <a:off x="5074920" y="3840480"/>
+            <a:ext cx="1005840" cy="502920"/>
+          </a:xfrm>
+          <a:prstGeom prst="rect">
+            <a:avLst/>
+          </a:prstGeom>
+          <a:solidFill>
+            <a:srgbClr val="F4B400"/>
+          </a:solidFill>
+          <a:ln>
+            <a:noFill/>
+          </a:ln>
+        </p:spPr>
+        <p:style>
+          <a:lnRef idx="1">
+            <a:schemeClr val="accent1"/>
+          </a:lnRef>
+          <a:fillRef idx="3">
+            <a:schemeClr val="accent1"/>
+          </a:fillRef>
+          <a:effectRef idx="2">
+            <a:schemeClr val="accent1"/>
+          </a:effectRef>
+          <a:fontRef idx="minor">
+            <a:schemeClr val="lt1"/>
+          </a:fontRef>
+        </p:style>
+        <p:txBody>
+          <a:bodyPr rtlCol="0" anchor="ctr"/>
+          <a:lstStyle/>
+          <a:p>
+            <a:pPr algn="ctr"/>
+          </a:p>
+        </p:txBody>
+      </p:sp>
+      <p:sp>
+        <p:nvSpPr>
+          <p:cNvPr id="13" name="TextBox 12"/>
+          <p:cNvSpPr txBox="1"/>
+          <p:nvPr/>
+        </p:nvSpPr>
+        <p:spPr>
+          <a:xfrm>
+            <a:off x="5074920" y="4434840"/>
+            <a:ext cx="1097280" cy="411480"/>
+          </a:xfrm>
+          <a:prstGeom prst="rect">
+            <a:avLst/>
+          </a:prstGeom>
+          <a:noFill/>
+        </p:spPr>
+        <p:txBody>
+          <a:bodyPr wrap="none">
+            <a:spAutoFit/>
+          </a:bodyPr>
+          <a:lstStyle/>
+          <a:p>
+            <a:pPr>
+              <a:defRPr sz="1000">
+                <a:solidFill>
+                  <a:srgbClr val="475569"/>
+                </a:solidFill>
+                <a:latin typeface="Aptos"/>
+              </a:defRPr>
+            </a:pPr>
+            <a:r>
+              <a:t>Highlight</a:t>
+            </a:r>
+          </a:p>
+        </p:txBody>
+      </p:sp>
+      <p:sp>
+        <p:nvSpPr>
+          <p:cNvPr id="14" name="TextBox 13"/>
+          <p:cNvSpPr txBox="1"/>
+          <p:nvPr/>
+        </p:nvSpPr>
+        <p:spPr>
+          <a:xfrm>
+            <a:off x="822960" y="6172200"/>
+            <a:ext cx="4572000" cy="320040"/>
+          </a:xfrm>
+          <a:prstGeom prst="rect">
+            <a:avLst/>
+          </a:prstGeom>
+          <a:noFill/>
+        </p:spPr>
+        <p:txBody>
+          <a:bodyPr wrap="none">
+            <a:spAutoFit/>
+          </a:bodyPr>
+          <a:lstStyle/>
+          <a:p>
+            <a:pPr>
+              <a:defRPr sz="1000">
+                <a:solidFill>
+                  <a:srgbClr val="475569"/>
+                </a:solidFill>
+                <a:latin typeface="Aptos"/>
+              </a:defRPr>
+            </a:pPr>
+            <a:r>
+              <a:t>Sample upload asset | Q1 business review experiment</a:t>
             </a:r>
           </a:p>
         </p:txBody>

</xml_diff>

<commit_message>
Refresh business report sample uploads
</commit_message>
<xml_diff>
--- a/sample_uploads/template.pptx
+++ b/sample_uploads/template.pptx
@@ -6,6 +6,11 @@
   </p:sldMasterIdLst>
   <p:sldIdLst>
     <p:sldId id="256" r:id="rId7"/>
+    <p:sldId id="257" r:id="rId8"/>
+    <p:sldId id="258" r:id="rId9"/>
+    <p:sldId id="259" r:id="rId10"/>
+    <p:sldId id="260" r:id="rId11"/>
+    <p:sldId id="261" r:id="rId12"/>
   </p:sldIdLst>
   <p:sldSz cx="12191695" cy="6858000" type="screen4x3"/>
   <p:notesSz cx="6858000" cy="9144000"/>
@@ -105,6 +110,159 @@
     </a:lvl9pPr>
   </p:defaultTextStyle>
 </p:presentation>
+</file>
+
+<file path=ppt/charts/chart1.xml><?xml version="1.0" encoding="utf-8"?>
+<c:chartSpace xmlns:c="http://schemas.openxmlformats.org/drawingml/2006/chart" xmlns:a="http://schemas.openxmlformats.org/drawingml/2006/main" xmlns:r="http://schemas.openxmlformats.org/officeDocument/2006/relationships">
+  <c:date1904 val="0"/>
+  <c:chart>
+    <c:title>
+      <c:tx>
+        <c:rich>
+          <a:bodyPr/>
+          <a:lstStyle/>
+          <a:p>
+            <a:r>
+              <a:t>Monthly revenue, Q1 baseline</a:t>
+            </a:r>
+          </a:p>
+        </c:rich>
+      </c:tx>
+      <c:layout/>
+      <c:overlay val="0"/>
+    </c:title>
+    <c:autoTitleDeleted val="0"/>
+    <c:plotArea>
+      <c:lineChart>
+        <c:grouping val="standard"/>
+        <c:varyColors val="0"/>
+        <c:ser>
+          <c:idx val="0"/>
+          <c:order val="0"/>
+          <c:tx>
+            <c:strRef>
+              <c:f>Sheet1!$B$1</c:f>
+              <c:strCache>
+                <c:ptCount val="1"/>
+                <c:pt idx="0">
+                  <c:v>Q1 Revenue</c:v>
+                </c:pt>
+              </c:strCache>
+            </c:strRef>
+          </c:tx>
+          <c:cat>
+            <c:strRef>
+              <c:f>Sheet1!$A$2:$A$7</c:f>
+              <c:strCache>
+                <c:ptCount val="6"/>
+                <c:pt idx="0">
+                  <c:v>Oct</c:v>
+                </c:pt>
+                <c:pt idx="1">
+                  <c:v>Nov</c:v>
+                </c:pt>
+                <c:pt idx="2">
+                  <c:v>Dec</c:v>
+                </c:pt>
+                <c:pt idx="3">
+                  <c:v>Jan</c:v>
+                </c:pt>
+                <c:pt idx="4">
+                  <c:v>Feb</c:v>
+                </c:pt>
+                <c:pt idx="5">
+                  <c:v>Mar</c:v>
+                </c:pt>
+              </c:strCache>
+            </c:strRef>
+          </c:cat>
+          <c:val>
+            <c:numRef>
+              <c:f>Sheet1!$B$2:$B$7</c:f>
+              <c:numCache>
+                <c:formatCode>General</c:formatCode>
+                <c:ptCount val="6"/>
+                <c:pt idx="0">
+                  <c:v>3.5</c:v>
+                </c:pt>
+                <c:pt idx="1">
+                  <c:v>3.8</c:v>
+                </c:pt>
+                <c:pt idx="2">
+                  <c:v>4.0</c:v>
+                </c:pt>
+                <c:pt idx="3">
+                  <c:v>3.9</c:v>
+                </c:pt>
+                <c:pt idx="4">
+                  <c:v>4.1</c:v>
+                </c:pt>
+                <c:pt idx="5">
+                  <c:v>4.4</c:v>
+                </c:pt>
+              </c:numCache>
+            </c:numRef>
+          </c:val>
+          <c:smooth val="0"/>
+        </c:ser>
+        <c:marker val="1"/>
+        <c:smooth val="0"/>
+        <c:axId val="2118791784"/>
+        <c:axId val="2140495176"/>
+      </c:lineChart>
+      <c:catAx>
+        <c:axId val="2118791784"/>
+        <c:scaling>
+          <c:orientation val="minMax"/>
+        </c:scaling>
+        <c:delete val="0"/>
+        <c:axPos val="b"/>
+        <c:majorTickMark val="out"/>
+        <c:minorTickMark val="none"/>
+        <c:tickLblPos val="nextTo"/>
+        <c:crossAx val="2140495176"/>
+        <c:crosses val="autoZero"/>
+        <c:auto val="1"/>
+        <c:lblAlgn val="ctr"/>
+        <c:lblOffset val="100"/>
+        <c:noMultiLvlLbl val="0"/>
+      </c:catAx>
+      <c:valAx>
+        <c:axId val="2140495176"/>
+        <c:scaling/>
+        <c:delete val="0"/>
+        <c:axPos val="l"/>
+        <c:majorGridlines/>
+        <c:majorTickMark val="out"/>
+        <c:minorTickMark val="none"/>
+        <c:tickLblPos val="nextTo"/>
+        <c:crossAx val="2118791784"/>
+        <c:crosses val="autoZero"/>
+      </c:valAx>
+    </c:plotArea>
+    <c:legend>
+      <c:legendPos val="b"/>
+      <c:layout/>
+      <c:overlay val="0"/>
+    </c:legend>
+    <c:plotVisOnly val="1"/>
+    <c:dispBlanksAs val="gap"/>
+    <c:showDLblsOverMax val="0"/>
+  </c:chart>
+  <c:txPr>
+    <a:bodyPr/>
+    <a:lstStyle/>
+    <a:p>
+      <a:pPr>
+        <a:defRPr sz="1800"/>
+      </a:pPr>
+      <a:endParaRPr lang="en-US"/>
+    </a:p>
+  </c:txPr>
+  <c:externalData r:id="rId1">
+    <c:autoUpdate val="0"/>
+  </c:externalData>
+</c:chartSpace>
 </file>
 
 <file path=ppt/slideLayouts/slideLayout1.xml><?xml version="1.0" encoding="utf-8"?>
@@ -3084,7 +3242,7 @@
     <p:bg>
       <p:bgPr>
         <a:solidFill>
-          <a:srgbClr val="F6F8FB"/>
+          <a:srgbClr val="0F2038"/>
         </a:solidFill>
         <a:effectLst/>
       </p:bgPr>
@@ -3105,13 +3263,13 @@
         <p:spPr>
           <a:xfrm>
             <a:off x="0" y="0"/>
-            <a:ext cx="12191695" cy="164592"/>
+            <a:ext cx="12191695" cy="6858000"/>
           </a:xfrm>
           <a:prstGeom prst="rect">
             <a:avLst/>
           </a:prstGeom>
           <a:solidFill>
-            <a:srgbClr val="014986"/>
+            <a:srgbClr val="0F2038"/>
           </a:solidFill>
           <a:ln>
             <a:noFill/>
@@ -3147,14 +3305,14 @@
         </p:nvSpPr>
         <p:spPr>
           <a:xfrm>
-            <a:off x="0" y="0"/>
-            <a:ext cx="320040" cy="6858000"/>
+            <a:off x="0" y="5440680"/>
+            <a:ext cx="12191695" cy="1417320"/>
           </a:xfrm>
           <a:prstGeom prst="rect">
             <a:avLst/>
           </a:prstGeom>
           <a:solidFill>
-            <a:srgbClr val="001F3F"/>
+            <a:srgbClr val="0057A4"/>
           </a:solidFill>
           <a:ln>
             <a:noFill/>
@@ -3184,25 +3342,216 @@
       </p:sp>
       <p:sp>
         <p:nvSpPr>
-          <p:cNvPr id="4" name="Rectangle 3"/>
+          <p:cNvPr id="4" name="TextBox 3"/>
+          <p:cNvSpPr txBox="1"/>
+          <p:nvPr/>
+        </p:nvSpPr>
+        <p:spPr>
+          <a:xfrm>
+            <a:off x="685800" y="1005840"/>
+            <a:ext cx="6858000" cy="731520"/>
+          </a:xfrm>
+          <a:prstGeom prst="rect">
+            <a:avLst/>
+          </a:prstGeom>
+          <a:noFill/>
+        </p:spPr>
+        <p:txBody>
+          <a:bodyPr wrap="square">
+            <a:spAutoFit/>
+          </a:bodyPr>
+          <a:lstStyle/>
+          <a:p>
+            <a:pPr algn="l"/>
+            <a:r>
+              <a:rPr sz="3600" b="1">
+                <a:solidFill>
+                  <a:srgbClr val="FFFFFF"/>
+                </a:solidFill>
+                <a:latin typeface="Aptos"/>
+              </a:rPr>
+              <a:t>Q1 2026 Business Review</a:t>
+            </a:r>
+          </a:p>
+        </p:txBody>
+      </p:sp>
+      <p:sp>
+        <p:nvSpPr>
+          <p:cNvPr id="5" name="TextBox 4"/>
+          <p:cNvSpPr txBox="1"/>
+          <p:nvPr/>
+        </p:nvSpPr>
+        <p:spPr>
+          <a:xfrm>
+            <a:off x="713232" y="1828800"/>
+            <a:ext cx="6766560" cy="457200"/>
+          </a:xfrm>
+          <a:prstGeom prst="rect">
+            <a:avLst/>
+          </a:prstGeom>
+          <a:noFill/>
+        </p:spPr>
+        <p:txBody>
+          <a:bodyPr wrap="square">
+            <a:spAutoFit/>
+          </a:bodyPr>
+          <a:lstStyle/>
+          <a:p>
+            <a:pPr algn="l"/>
+            <a:r>
+              <a:rPr sz="1600" b="0">
+                <a:solidFill>
+                  <a:srgbClr val="CBD5E1"/>
+                </a:solidFill>
+                <a:latin typeface="Aptos"/>
+              </a:rPr>
+              <a:t>Revenue momentum, customer health, and operating priorities</a:t>
+            </a:r>
+          </a:p>
+        </p:txBody>
+      </p:sp>
+      <p:sp>
+        <p:nvSpPr>
+          <p:cNvPr id="6" name="TextBox 5"/>
+          <p:cNvSpPr txBox="1"/>
+          <p:nvPr/>
+        </p:nvSpPr>
+        <p:spPr>
+          <a:xfrm>
+            <a:off x="713232" y="2423160"/>
+            <a:ext cx="4754880" cy="320040"/>
+          </a:xfrm>
+          <a:prstGeom prst="rect">
+            <a:avLst/>
+          </a:prstGeom>
+          <a:noFill/>
+        </p:spPr>
+        <p:txBody>
+          <a:bodyPr wrap="square">
+            <a:spAutoFit/>
+          </a:bodyPr>
+          <a:lstStyle/>
+          <a:p>
+            <a:pPr algn="l"/>
+            <a:r>
+              <a:rPr sz="1100" b="0">
+                <a:solidFill>
+                  <a:srgbClr val="CBD5E1"/>
+                </a:solidFill>
+                <a:latin typeface="Aptos"/>
+              </a:rPr>
+              <a:t>Prepared for Board of Directors | April 2026</a:t>
+            </a:r>
+          </a:p>
+        </p:txBody>
+      </p:sp>
+      <p:sp>
+        <p:nvSpPr>
+          <p:cNvPr id="7" name="TextBox 6"/>
+          <p:cNvSpPr txBox="1"/>
+          <p:nvPr/>
+        </p:nvSpPr>
+        <p:spPr>
+          <a:xfrm>
+            <a:off x="713232" y="5715000"/>
+            <a:ext cx="7863840" cy="384048"/>
+          </a:xfrm>
+          <a:prstGeom prst="rect">
+            <a:avLst/>
+          </a:prstGeom>
+          <a:noFill/>
+        </p:spPr>
+        <p:txBody>
+          <a:bodyPr wrap="square">
+            <a:spAutoFit/>
+          </a:bodyPr>
+          <a:lstStyle/>
+          <a:p>
+            <a:pPr algn="l"/>
+            <a:r>
+              <a:rPr sz="1800" b="1">
+                <a:solidFill>
+                  <a:srgbClr val="FFFFFF"/>
+                </a:solidFill>
+                <a:latin typeface="Aptos"/>
+              </a:rPr>
+              <a:t>Q1 closed with $12.4M revenue and 64% gross margin</a:t>
+            </a:r>
+          </a:p>
+        </p:txBody>
+      </p:sp>
+      <p:sp>
+        <p:nvSpPr>
+          <p:cNvPr id="8" name="TextBox 7"/>
+          <p:cNvSpPr txBox="1"/>
+          <p:nvPr/>
+        </p:nvSpPr>
+        <p:spPr>
+          <a:xfrm>
+            <a:off x="731520" y="6199632"/>
+            <a:ext cx="6217920" cy="228600"/>
+          </a:xfrm>
+          <a:prstGeom prst="rect">
+            <a:avLst/>
+          </a:prstGeom>
+          <a:noFill/>
+        </p:spPr>
+        <p:txBody>
+          <a:bodyPr wrap="square">
+            <a:spAutoFit/>
+          </a:bodyPr>
+          <a:lstStyle/>
+          <a:p>
+            <a:pPr algn="l"/>
+            <a:r>
+              <a:rPr sz="800" b="0">
+                <a:solidFill>
+                  <a:srgbClr val="CBD5E1"/>
+                </a:solidFill>
+                <a:latin typeface="Aptos"/>
+              </a:rPr>
+              <a:t>Template anchor: replace this slide with the latest quarter narrative.</a:t>
+            </a:r>
+          </a:p>
+        </p:txBody>
+      </p:sp>
+    </p:spTree>
+  </p:cSld>
+  <p:clrMapOvr>
+    <a:masterClrMapping/>
+  </p:clrMapOvr>
+</p:sld>
+</file>
+
+<file path=ppt/slides/slide2.xml><?xml version="1.0" encoding="utf-8"?>
+<p:sld xmlns:a="http://schemas.openxmlformats.org/drawingml/2006/main" xmlns:p="http://schemas.openxmlformats.org/presentationml/2006/main" xmlns:r="http://schemas.openxmlformats.org/officeDocument/2006/relationships">
+  <p:cSld>
+    <p:spTree>
+      <p:nvGrpSpPr>
+        <p:cNvPr id="1" name=""/>
+        <p:cNvGrpSpPr/>
+        <p:nvPr/>
+      </p:nvGrpSpPr>
+      <p:grpSpPr/>
+      <p:sp>
+        <p:nvSpPr>
+          <p:cNvPr id="2" name="Rectangle 1"/>
           <p:cNvSpPr/>
           <p:nvPr/>
         </p:nvSpPr>
         <p:spPr>
           <a:xfrm>
-            <a:off x="822960" y="914400"/>
-            <a:ext cx="4846320" cy="1417320"/>
+            <a:off x="0" y="0"/>
+            <a:ext cx="12191695" cy="164592"/>
           </a:xfrm>
           <a:prstGeom prst="rect">
             <a:avLst/>
           </a:prstGeom>
           <a:solidFill>
-            <a:srgbClr val="FFFFFF"/>
+            <a:srgbClr val="0057A4"/>
           </a:solidFill>
           <a:ln>
-            <a:solidFill>
-              <a:srgbClr val="E2E8F0"/>
-            </a:solidFill>
+            <a:noFill/>
           </a:ln>
         </p:spPr>
         <p:style>
@@ -3223,29 +3572,76 @@
           <a:bodyPr rtlCol="0" anchor="ctr"/>
           <a:lstStyle/>
           <a:p>
-            <a:pPr>
-              <a:defRPr sz="2600" b="1">
-                <a:solidFill>
-                  <a:srgbClr val="001F3F"/>
-                </a:solidFill>
-                <a:latin typeface="Aptos Display"/>
-              </a:defRPr>
-            </a:pPr>
-            <a:r>
-              <a:t>Prompt-to-PPT</a:t>
-            </a:r>
-          </a:p>
-          <a:p>
-            <a:pPr>
-              <a:defRPr sz="1600" b="0">
-                <a:solidFill>
-                  <a:srgbClr val="475569"/>
-                </a:solidFill>
-                <a:latin typeface="Aptos Display"/>
-              </a:defRPr>
-            </a:pPr>
-            <a:r>
-              <a:t>Corporate Review Template</a:t>
+            <a:pPr algn="ctr"/>
+          </a:p>
+        </p:txBody>
+      </p:sp>
+      <p:sp>
+        <p:nvSpPr>
+          <p:cNvPr id="3" name="TextBox 2"/>
+          <p:cNvSpPr txBox="1"/>
+          <p:nvPr/>
+        </p:nvSpPr>
+        <p:spPr>
+          <a:xfrm>
+            <a:off x="502920" y="256032"/>
+            <a:ext cx="3108960" cy="228600"/>
+          </a:xfrm>
+          <a:prstGeom prst="rect">
+            <a:avLst/>
+          </a:prstGeom>
+          <a:noFill/>
+        </p:spPr>
+        <p:txBody>
+          <a:bodyPr wrap="square">
+            <a:spAutoFit/>
+          </a:bodyPr>
+          <a:lstStyle/>
+          <a:p>
+            <a:pPr algn="l"/>
+            <a:r>
+              <a:rPr sz="700" b="1">
+                <a:solidFill>
+                  <a:srgbClr val="64748B"/>
+                </a:solidFill>
+                <a:latin typeface="Aptos"/>
+              </a:rPr>
+              <a:t>CONFIDENTIAL BUSINESS REVIEW</a:t>
+            </a:r>
+          </a:p>
+        </p:txBody>
+      </p:sp>
+      <p:sp>
+        <p:nvSpPr>
+          <p:cNvPr id="4" name="TextBox 3"/>
+          <p:cNvSpPr txBox="1"/>
+          <p:nvPr/>
+        </p:nvSpPr>
+        <p:spPr>
+          <a:xfrm>
+            <a:off x="502920" y="530352"/>
+            <a:ext cx="8046720" cy="438912"/>
+          </a:xfrm>
+          <a:prstGeom prst="rect">
+            <a:avLst/>
+          </a:prstGeom>
+          <a:noFill/>
+        </p:spPr>
+        <p:txBody>
+          <a:bodyPr wrap="square">
+            <a:spAutoFit/>
+          </a:bodyPr>
+          <a:lstStyle/>
+          <a:p>
+            <a:pPr algn="l"/>
+            <a:r>
+              <a:rPr sz="2300" b="1">
+                <a:solidFill>
+                  <a:srgbClr val="0F2038"/>
+                </a:solidFill>
+                <a:latin typeface="Aptos"/>
+              </a:rPr>
+              <a:t>Executive scorecard</a:t>
             </a:r>
           </a:p>
         </p:txBody>
@@ -3258,53 +3654,59 @@
         </p:nvSpPr>
         <p:spPr>
           <a:xfrm>
-            <a:off x="822960" y="2606040"/>
-            <a:ext cx="6400800" cy="548640"/>
+            <a:off x="10378440" y="393192"/>
+            <a:ext cx="1234440" cy="320040"/>
           </a:xfrm>
           <a:prstGeom prst="rect">
             <a:avLst/>
           </a:prstGeom>
-          <a:noFill/>
-        </p:spPr>
-        <p:txBody>
-          <a:bodyPr wrap="none">
-            <a:spAutoFit/>
-          </a:bodyPr>
-          <a:lstStyle/>
-          <a:p>
-            <a:pPr>
-              <a:defRPr sz="1500">
-                <a:solidFill>
-                  <a:srgbClr val="475569"/>
-                </a:solidFill>
-                <a:latin typeface="Aptos"/>
-              </a:defRPr>
-            </a:pPr>
-            <a:r>
-              <a:t>Use this file as the template input. Generated slides will inherit this navy, teal, and gold business-review style.</a:t>
-            </a:r>
-          </a:p>
-        </p:txBody>
-      </p:sp>
-      <p:sp>
-        <p:nvSpPr>
-          <p:cNvPr id="6" name="Rectangle 5"/>
-          <p:cNvSpPr/>
-          <p:nvPr/>
-        </p:nvSpPr>
-        <p:spPr>
-          <a:xfrm>
-            <a:off x="822960" y="3840480"/>
-            <a:ext cx="1005840" cy="502920"/>
-          </a:xfrm>
-          <a:prstGeom prst="rect">
-            <a:avLst/>
-          </a:prstGeom>
           <a:solidFill>
-            <a:srgbClr val="001F3F"/>
+            <a:srgbClr val="F58220"/>
           </a:solidFill>
           <a:ln>
             <a:noFill/>
+          </a:ln>
+        </p:spPr>
+        <p:txBody>
+          <a:bodyPr wrap="square">
+            <a:spAutoFit/>
+          </a:bodyPr>
+          <a:lstStyle/>
+          <a:p>
+            <a:pPr algn="ctr"/>
+            <a:r>
+              <a:rPr sz="1000" b="1">
+                <a:solidFill>
+                  <a:srgbClr val="FFFFFF"/>
+                </a:solidFill>
+                <a:latin typeface="Aptos"/>
+              </a:rPr>
+              <a:t>Q1 2026</a:t>
+            </a:r>
+          </a:p>
+        </p:txBody>
+      </p:sp>
+      <p:sp>
+        <p:nvSpPr>
+          <p:cNvPr id="6" name="Rounded Rectangle 5"/>
+          <p:cNvSpPr/>
+          <p:nvPr/>
+        </p:nvSpPr>
+        <p:spPr>
+          <a:xfrm>
+            <a:off x="594360" y="1417320"/>
+            <a:ext cx="2606040" cy="1234440"/>
+          </a:xfrm>
+          <a:prstGeom prst="roundRect">
+            <a:avLst/>
+          </a:prstGeom>
+          <a:solidFill>
+            <a:srgbClr val="FFFFFF"/>
+          </a:solidFill>
+          <a:ln w="12700">
+            <a:solidFill>
+              <a:srgbClr val="E2E8F0"/>
+            </a:solidFill>
           </a:ln>
         </p:spPr>
         <p:style>
@@ -3337,8 +3739,8 @@
         </p:nvSpPr>
         <p:spPr>
           <a:xfrm>
-            <a:off x="822960" y="4434840"/>
-            <a:ext cx="1097280" cy="411480"/>
+            <a:off x="758952" y="1581912"/>
+            <a:ext cx="2276856" cy="228600"/>
           </a:xfrm>
           <a:prstGeom prst="rect">
             <a:avLst/>
@@ -3346,44 +3748,115 @@
           <a:noFill/>
         </p:spPr>
         <p:txBody>
-          <a:bodyPr wrap="none">
+          <a:bodyPr wrap="square">
             <a:spAutoFit/>
           </a:bodyPr>
           <a:lstStyle/>
           <a:p>
-            <a:pPr>
-              <a:defRPr sz="1000">
-                <a:solidFill>
-                  <a:srgbClr val="475569"/>
-                </a:solidFill>
-                <a:latin typeface="Aptos"/>
-              </a:defRPr>
-            </a:pPr>
-            <a:r>
-              <a:t>Primary</a:t>
-            </a:r>
-          </a:p>
-        </p:txBody>
-      </p:sp>
-      <p:sp>
-        <p:nvSpPr>
-          <p:cNvPr id="8" name="Rectangle 7"/>
+            <a:pPr algn="l"/>
+            <a:r>
+              <a:rPr sz="900" b="1">
+                <a:solidFill>
+                  <a:srgbClr val="64748B"/>
+                </a:solidFill>
+                <a:latin typeface="Aptos"/>
+              </a:rPr>
+              <a:t>Revenue</a:t>
+            </a:r>
+          </a:p>
+        </p:txBody>
+      </p:sp>
+      <p:sp>
+        <p:nvSpPr>
+          <p:cNvPr id="8" name="TextBox 7"/>
+          <p:cNvSpPr txBox="1"/>
+          <p:nvPr/>
+        </p:nvSpPr>
+        <p:spPr>
+          <a:xfrm>
+            <a:off x="758952" y="1856232"/>
+            <a:ext cx="2276856" cy="411480"/>
+          </a:xfrm>
+          <a:prstGeom prst="rect">
+            <a:avLst/>
+          </a:prstGeom>
+          <a:noFill/>
+        </p:spPr>
+        <p:txBody>
+          <a:bodyPr wrap="square">
+            <a:spAutoFit/>
+          </a:bodyPr>
+          <a:lstStyle/>
+          <a:p>
+            <a:pPr algn="l"/>
+            <a:r>
+              <a:rPr sz="2100" b="1">
+                <a:solidFill>
+                  <a:srgbClr val="0057A4"/>
+                </a:solidFill>
+                <a:latin typeface="Aptos"/>
+              </a:rPr>
+              <a:t>$12.4M</a:t>
+            </a:r>
+          </a:p>
+        </p:txBody>
+      </p:sp>
+      <p:sp>
+        <p:nvSpPr>
+          <p:cNvPr id="9" name="TextBox 8"/>
+          <p:cNvSpPr txBox="1"/>
+          <p:nvPr/>
+        </p:nvSpPr>
+        <p:spPr>
+          <a:xfrm>
+            <a:off x="758952" y="2313432"/>
+            <a:ext cx="2276856" cy="320040"/>
+          </a:xfrm>
+          <a:prstGeom prst="rect">
+            <a:avLst/>
+          </a:prstGeom>
+          <a:noFill/>
+        </p:spPr>
+        <p:txBody>
+          <a:bodyPr wrap="square">
+            <a:spAutoFit/>
+          </a:bodyPr>
+          <a:lstStyle/>
+          <a:p>
+            <a:pPr algn="l"/>
+            <a:r>
+              <a:rPr sz="800" b="0">
+                <a:solidFill>
+                  <a:srgbClr val="64748B"/>
+                </a:solidFill>
+                <a:latin typeface="Aptos"/>
+              </a:rPr>
+              <a:t>+8% QoQ in Q1</a:t>
+            </a:r>
+          </a:p>
+        </p:txBody>
+      </p:sp>
+      <p:sp>
+        <p:nvSpPr>
+          <p:cNvPr id="10" name="Rounded Rectangle 9"/>
           <p:cNvSpPr/>
           <p:nvPr/>
         </p:nvSpPr>
         <p:spPr>
           <a:xfrm>
-            <a:off x="2240280" y="3840480"/>
-            <a:ext cx="1005840" cy="502920"/>
-          </a:xfrm>
-          <a:prstGeom prst="rect">
+            <a:off x="3429000" y="1417320"/>
+            <a:ext cx="2606040" cy="1234440"/>
+          </a:xfrm>
+          <a:prstGeom prst="roundRect">
             <a:avLst/>
           </a:prstGeom>
           <a:solidFill>
-            <a:srgbClr val="014986"/>
+            <a:srgbClr val="FFFFFF"/>
           </a:solidFill>
-          <a:ln>
-            <a:noFill/>
+          <a:ln w="12700">
+            <a:solidFill>
+              <a:srgbClr val="E2E8F0"/>
+            </a:solidFill>
           </a:ln>
         </p:spPr>
         <p:style>
@@ -3410,14 +3883,14 @@
       </p:sp>
       <p:sp>
         <p:nvSpPr>
-          <p:cNvPr id="9" name="TextBox 8"/>
+          <p:cNvPr id="11" name="TextBox 10"/>
           <p:cNvSpPr txBox="1"/>
           <p:nvPr/>
         </p:nvSpPr>
         <p:spPr>
           <a:xfrm>
-            <a:off x="2240280" y="4434840"/>
-            <a:ext cx="1097280" cy="411480"/>
+            <a:off x="3593592" y="1581912"/>
+            <a:ext cx="2276856" cy="228600"/>
           </a:xfrm>
           <a:prstGeom prst="rect">
             <a:avLst/>
@@ -3425,44 +3898,115 @@
           <a:noFill/>
         </p:spPr>
         <p:txBody>
-          <a:bodyPr wrap="none">
+          <a:bodyPr wrap="square">
             <a:spAutoFit/>
           </a:bodyPr>
           <a:lstStyle/>
           <a:p>
-            <a:pPr>
-              <a:defRPr sz="1000">
-                <a:solidFill>
-                  <a:srgbClr val="475569"/>
-                </a:solidFill>
-                <a:latin typeface="Aptos"/>
-              </a:defRPr>
-            </a:pPr>
-            <a:r>
-              <a:t>Accent</a:t>
-            </a:r>
-          </a:p>
-        </p:txBody>
-      </p:sp>
-      <p:sp>
-        <p:nvSpPr>
-          <p:cNvPr id="10" name="Rectangle 9"/>
+            <a:pPr algn="l"/>
+            <a:r>
+              <a:rPr sz="900" b="1">
+                <a:solidFill>
+                  <a:srgbClr val="64748B"/>
+                </a:solidFill>
+                <a:latin typeface="Aptos"/>
+              </a:rPr>
+              <a:t>Gross margin</a:t>
+            </a:r>
+          </a:p>
+        </p:txBody>
+      </p:sp>
+      <p:sp>
+        <p:nvSpPr>
+          <p:cNvPr id="12" name="TextBox 11"/>
+          <p:cNvSpPr txBox="1"/>
+          <p:nvPr/>
+        </p:nvSpPr>
+        <p:spPr>
+          <a:xfrm>
+            <a:off x="3593592" y="1856232"/>
+            <a:ext cx="2276856" cy="411480"/>
+          </a:xfrm>
+          <a:prstGeom prst="rect">
+            <a:avLst/>
+          </a:prstGeom>
+          <a:noFill/>
+        </p:spPr>
+        <p:txBody>
+          <a:bodyPr wrap="square">
+            <a:spAutoFit/>
+          </a:bodyPr>
+          <a:lstStyle/>
+          <a:p>
+            <a:pPr algn="l"/>
+            <a:r>
+              <a:rPr sz="2100" b="1">
+                <a:solidFill>
+                  <a:srgbClr val="14B8A6"/>
+                </a:solidFill>
+                <a:latin typeface="Aptos"/>
+              </a:rPr>
+              <a:t>64%</a:t>
+            </a:r>
+          </a:p>
+        </p:txBody>
+      </p:sp>
+      <p:sp>
+        <p:nvSpPr>
+          <p:cNvPr id="13" name="TextBox 12"/>
+          <p:cNvSpPr txBox="1"/>
+          <p:nvPr/>
+        </p:nvSpPr>
+        <p:spPr>
+          <a:xfrm>
+            <a:off x="3593592" y="2313432"/>
+            <a:ext cx="2276856" cy="320040"/>
+          </a:xfrm>
+          <a:prstGeom prst="rect">
+            <a:avLst/>
+          </a:prstGeom>
+          <a:noFill/>
+        </p:spPr>
+        <p:txBody>
+          <a:bodyPr wrap="square">
+            <a:spAutoFit/>
+          </a:bodyPr>
+          <a:lstStyle/>
+          <a:p>
+            <a:pPr algn="l"/>
+            <a:r>
+              <a:rPr sz="800" b="0">
+                <a:solidFill>
+                  <a:srgbClr val="64748B"/>
+                </a:solidFill>
+                <a:latin typeface="Aptos"/>
+              </a:rPr>
+              <a:t>+2 pts vs Q4</a:t>
+            </a:r>
+          </a:p>
+        </p:txBody>
+      </p:sp>
+      <p:sp>
+        <p:nvSpPr>
+          <p:cNvPr id="14" name="Rounded Rectangle 13"/>
           <p:cNvSpPr/>
           <p:nvPr/>
         </p:nvSpPr>
         <p:spPr>
           <a:xfrm>
-            <a:off x="3657600" y="3840480"/>
-            <a:ext cx="1005840" cy="502920"/>
-          </a:xfrm>
-          <a:prstGeom prst="rect">
+            <a:off x="6263640" y="1417320"/>
+            <a:ext cx="2606040" cy="1234440"/>
+          </a:xfrm>
+          <a:prstGeom prst="roundRect">
             <a:avLst/>
           </a:prstGeom>
           <a:solidFill>
-            <a:srgbClr val="149496"/>
+            <a:srgbClr val="FFFFFF"/>
           </a:solidFill>
-          <a:ln>
-            <a:noFill/>
+          <a:ln w="12700">
+            <a:solidFill>
+              <a:srgbClr val="E2E8F0"/>
+            </a:solidFill>
           </a:ln>
         </p:spPr>
         <p:style>
@@ -3489,14 +4033,14 @@
       </p:sp>
       <p:sp>
         <p:nvSpPr>
-          <p:cNvPr id="11" name="TextBox 10"/>
+          <p:cNvPr id="15" name="TextBox 14"/>
           <p:cNvSpPr txBox="1"/>
           <p:nvPr/>
         </p:nvSpPr>
         <p:spPr>
           <a:xfrm>
-            <a:off x="3657600" y="4434840"/>
-            <a:ext cx="1097280" cy="411480"/>
+            <a:off x="6428231" y="1581912"/>
+            <a:ext cx="2276856" cy="228600"/>
           </a:xfrm>
           <a:prstGeom prst="rect">
             <a:avLst/>
@@ -3504,44 +4048,115 @@
           <a:noFill/>
         </p:spPr>
         <p:txBody>
-          <a:bodyPr wrap="none">
+          <a:bodyPr wrap="square">
             <a:spAutoFit/>
           </a:bodyPr>
           <a:lstStyle/>
           <a:p>
-            <a:pPr>
-              <a:defRPr sz="1000">
-                <a:solidFill>
-                  <a:srgbClr val="475569"/>
-                </a:solidFill>
-                <a:latin typeface="Aptos"/>
-              </a:defRPr>
-            </a:pPr>
-            <a:r>
-              <a:t>Signal</a:t>
-            </a:r>
-          </a:p>
-        </p:txBody>
-      </p:sp>
-      <p:sp>
-        <p:nvSpPr>
-          <p:cNvPr id="12" name="Rectangle 11"/>
+            <a:pPr algn="l"/>
+            <a:r>
+              <a:rPr sz="900" b="1">
+                <a:solidFill>
+                  <a:srgbClr val="64748B"/>
+                </a:solidFill>
+                <a:latin typeface="Aptos"/>
+              </a:rPr>
+              <a:t>Net revenue retention</a:t>
+            </a:r>
+          </a:p>
+        </p:txBody>
+      </p:sp>
+      <p:sp>
+        <p:nvSpPr>
+          <p:cNvPr id="16" name="TextBox 15"/>
+          <p:cNvSpPr txBox="1"/>
+          <p:nvPr/>
+        </p:nvSpPr>
+        <p:spPr>
+          <a:xfrm>
+            <a:off x="6428231" y="1856232"/>
+            <a:ext cx="2276856" cy="411480"/>
+          </a:xfrm>
+          <a:prstGeom prst="rect">
+            <a:avLst/>
+          </a:prstGeom>
+          <a:noFill/>
+        </p:spPr>
+        <p:txBody>
+          <a:bodyPr wrap="square">
+            <a:spAutoFit/>
+          </a:bodyPr>
+          <a:lstStyle/>
+          <a:p>
+            <a:pPr algn="l"/>
+            <a:r>
+              <a:rPr sz="2100" b="1">
+                <a:solidFill>
+                  <a:srgbClr val="F58220"/>
+                </a:solidFill>
+                <a:latin typeface="Aptos"/>
+              </a:rPr>
+              <a:t>111%</a:t>
+            </a:r>
+          </a:p>
+        </p:txBody>
+      </p:sp>
+      <p:sp>
+        <p:nvSpPr>
+          <p:cNvPr id="17" name="TextBox 16"/>
+          <p:cNvSpPr txBox="1"/>
+          <p:nvPr/>
+        </p:nvSpPr>
+        <p:spPr>
+          <a:xfrm>
+            <a:off x="6428231" y="2313432"/>
+            <a:ext cx="2276856" cy="320040"/>
+          </a:xfrm>
+          <a:prstGeom prst="rect">
+            <a:avLst/>
+          </a:prstGeom>
+          <a:noFill/>
+        </p:spPr>
+        <p:txBody>
+          <a:bodyPr wrap="square">
+            <a:spAutoFit/>
+          </a:bodyPr>
+          <a:lstStyle/>
+          <a:p>
+            <a:pPr algn="l"/>
+            <a:r>
+              <a:rPr sz="800" b="0">
+                <a:solidFill>
+                  <a:srgbClr val="64748B"/>
+                </a:solidFill>
+                <a:latin typeface="Aptos"/>
+              </a:rPr>
+              <a:t>Enterprise expansion led</a:t>
+            </a:r>
+          </a:p>
+        </p:txBody>
+      </p:sp>
+      <p:sp>
+        <p:nvSpPr>
+          <p:cNvPr id="18" name="Rounded Rectangle 17"/>
           <p:cNvSpPr/>
           <p:nvPr/>
         </p:nvSpPr>
         <p:spPr>
           <a:xfrm>
-            <a:off x="5074920" y="3840480"/>
-            <a:ext cx="1005840" cy="502920"/>
-          </a:xfrm>
-          <a:prstGeom prst="rect">
+            <a:off x="9098280" y="1417320"/>
+            <a:ext cx="2606040" cy="1234440"/>
+          </a:xfrm>
+          <a:prstGeom prst="roundRect">
             <a:avLst/>
           </a:prstGeom>
           <a:solidFill>
-            <a:srgbClr val="F4B400"/>
+            <a:srgbClr val="FFFFFF"/>
           </a:solidFill>
-          <a:ln>
-            <a:noFill/>
+          <a:ln w="12700">
+            <a:solidFill>
+              <a:srgbClr val="E2E8F0"/>
+            </a:solidFill>
           </a:ln>
         </p:spPr>
         <p:style>
@@ -3568,14 +4183,14 @@
       </p:sp>
       <p:sp>
         <p:nvSpPr>
-          <p:cNvPr id="13" name="TextBox 12"/>
+          <p:cNvPr id="19" name="TextBox 18"/>
           <p:cNvSpPr txBox="1"/>
           <p:nvPr/>
         </p:nvSpPr>
         <p:spPr>
           <a:xfrm>
-            <a:off x="5074920" y="4434840"/>
-            <a:ext cx="1097280" cy="411480"/>
+            <a:off x="9262872" y="1581912"/>
+            <a:ext cx="2276856" cy="228600"/>
           </a:xfrm>
           <a:prstGeom prst="rect">
             <a:avLst/>
@@ -3583,35 +4198,34 @@
           <a:noFill/>
         </p:spPr>
         <p:txBody>
-          <a:bodyPr wrap="none">
+          <a:bodyPr wrap="square">
             <a:spAutoFit/>
           </a:bodyPr>
           <a:lstStyle/>
           <a:p>
-            <a:pPr>
-              <a:defRPr sz="1000">
-                <a:solidFill>
-                  <a:srgbClr val="475569"/>
-                </a:solidFill>
-                <a:latin typeface="Aptos"/>
-              </a:defRPr>
-            </a:pPr>
-            <a:r>
-              <a:t>Highlight</a:t>
-            </a:r>
-          </a:p>
-        </p:txBody>
-      </p:sp>
-      <p:sp>
-        <p:nvSpPr>
-          <p:cNvPr id="14" name="TextBox 13"/>
+            <a:pPr algn="l"/>
+            <a:r>
+              <a:rPr sz="900" b="1">
+                <a:solidFill>
+                  <a:srgbClr val="64748B"/>
+                </a:solidFill>
+                <a:latin typeface="Aptos"/>
+              </a:rPr>
+              <a:t>Pipeline coverage</a:t>
+            </a:r>
+          </a:p>
+        </p:txBody>
+      </p:sp>
+      <p:sp>
+        <p:nvSpPr>
+          <p:cNvPr id="20" name="TextBox 19"/>
           <p:cNvSpPr txBox="1"/>
           <p:nvPr/>
         </p:nvSpPr>
         <p:spPr>
           <a:xfrm>
-            <a:off x="822960" y="6172200"/>
-            <a:ext cx="4572000" cy="320040"/>
+            <a:off x="9262872" y="1856232"/>
+            <a:ext cx="2276856" cy="411480"/>
           </a:xfrm>
           <a:prstGeom prst="rect">
             <a:avLst/>
@@ -3619,21 +4233,2391 @@
           <a:noFill/>
         </p:spPr>
         <p:txBody>
-          <a:bodyPr wrap="none">
+          <a:bodyPr wrap="square">
             <a:spAutoFit/>
           </a:bodyPr>
           <a:lstStyle/>
           <a:p>
-            <a:pPr>
-              <a:defRPr sz="1000">
-                <a:solidFill>
-                  <a:srgbClr val="475569"/>
-                </a:solidFill>
-                <a:latin typeface="Aptos"/>
-              </a:defRPr>
-            </a:pPr>
-            <a:r>
-              <a:t>Sample upload asset | Q1 business review experiment</a:t>
+            <a:pPr algn="l"/>
+            <a:r>
+              <a:rPr sz="2100" b="1">
+                <a:solidFill>
+                  <a:srgbClr val="0057A4"/>
+                </a:solidFill>
+                <a:latin typeface="Aptos"/>
+              </a:rPr>
+              <a:t>2.8x</a:t>
+            </a:r>
+          </a:p>
+        </p:txBody>
+      </p:sp>
+      <p:sp>
+        <p:nvSpPr>
+          <p:cNvPr id="21" name="TextBox 20"/>
+          <p:cNvSpPr txBox="1"/>
+          <p:nvPr/>
+        </p:nvSpPr>
+        <p:spPr>
+          <a:xfrm>
+            <a:off x="9262872" y="2313432"/>
+            <a:ext cx="2276856" cy="320040"/>
+          </a:xfrm>
+          <a:prstGeom prst="rect">
+            <a:avLst/>
+          </a:prstGeom>
+          <a:noFill/>
+        </p:spPr>
+        <p:txBody>
+          <a:bodyPr wrap="square">
+            <a:spAutoFit/>
+          </a:bodyPr>
+          <a:lstStyle/>
+          <a:p>
+            <a:pPr algn="l"/>
+            <a:r>
+              <a:rPr sz="800" b="0">
+                <a:solidFill>
+                  <a:srgbClr val="64748B"/>
+                </a:solidFill>
+                <a:latin typeface="Aptos"/>
+              </a:rPr>
+              <a:t>Q2 target coverage</a:t>
+            </a:r>
+          </a:p>
+        </p:txBody>
+      </p:sp>
+      <p:sp>
+        <p:nvSpPr>
+          <p:cNvPr id="22" name="TextBox 21"/>
+          <p:cNvSpPr txBox="1"/>
+          <p:nvPr/>
+        </p:nvSpPr>
+        <p:spPr>
+          <a:xfrm>
+            <a:off x="685800" y="3063240"/>
+            <a:ext cx="10698480" cy="502920"/>
+          </a:xfrm>
+          <a:prstGeom prst="rect">
+            <a:avLst/>
+          </a:prstGeom>
+          <a:noFill/>
+        </p:spPr>
+        <p:txBody>
+          <a:bodyPr wrap="square">
+            <a:spAutoFit/>
+          </a:bodyPr>
+          <a:lstStyle/>
+          <a:p>
+            <a:pPr algn="l"/>
+            <a:r>
+              <a:rPr sz="1700" b="1">
+                <a:solidFill>
+                  <a:srgbClr val="0F2038"/>
+                </a:solidFill>
+                <a:latin typeface="Aptos"/>
+              </a:rPr>
+              <a:t>Q1 headline: efficient growth continued, but enterprise conversion timing remained the main constraint.</a:t>
+            </a:r>
+          </a:p>
+        </p:txBody>
+      </p:sp>
+      <p:sp>
+        <p:nvSpPr>
+          <p:cNvPr id="23" name="TextBox 22"/>
+          <p:cNvSpPr txBox="1"/>
+          <p:nvPr/>
+        </p:nvSpPr>
+        <p:spPr>
+          <a:xfrm>
+            <a:off x="777240" y="3794760"/>
+            <a:ext cx="5166360" cy="1600200"/>
+          </a:xfrm>
+          <a:prstGeom prst="rect">
+            <a:avLst/>
+          </a:prstGeom>
+          <a:noFill/>
+        </p:spPr>
+        <p:txBody>
+          <a:bodyPr wrap="square">
+            <a:spAutoFit/>
+          </a:bodyPr>
+          <a:lstStyle/>
+          <a:p>
+            <a:pPr algn="l"/>
+            <a:r>
+              <a:rPr sz="1400" b="0">
+                <a:solidFill>
+                  <a:srgbClr val="0F2038"/>
+                </a:solidFill>
+                <a:latin typeface="Aptos"/>
+              </a:rPr>
+              <a:t>Key observations</a:t>
+            </a:r>
+            <a:br/>
+            <a:r>
+              <a:rPr sz="1400" b="0">
+                <a:solidFill>
+                  <a:srgbClr val="0F2038"/>
+                </a:solidFill>
+                <a:latin typeface="Aptos"/>
+              </a:rPr>
+              <a:t>- Enterprise ARR expanded 14% sequentially.</a:t>
+            </a:r>
+            <a:br/>
+            <a:r>
+              <a:rPr sz="1400" b="0">
+                <a:solidFill>
+                  <a:srgbClr val="0F2038"/>
+                </a:solidFill>
+                <a:latin typeface="Aptos"/>
+              </a:rPr>
+              <a:t>- SMB churn remained elevated at 3.1% monthly.</a:t>
+            </a:r>
+            <a:br/>
+            <a:r>
+              <a:rPr sz="1400" b="0">
+                <a:solidFill>
+                  <a:srgbClr val="0F2038"/>
+                </a:solidFill>
+                <a:latin typeface="Aptos"/>
+              </a:rPr>
+              <a:t>- Marketing CAC improved but sales cycle lengthened by 9 days.</a:t>
+            </a:r>
+            <a:br/>
+            <a:r>
+              <a:rPr sz="1400" b="0">
+                <a:solidFill>
+                  <a:srgbClr val="0F2038"/>
+                </a:solidFill>
+                <a:latin typeface="Aptos"/>
+              </a:rPr>
+              <a:t>- Hiring stayed within the approved operating plan.</a:t>
+            </a:r>
+          </a:p>
+        </p:txBody>
+      </p:sp>
+      <p:sp>
+        <p:nvSpPr>
+          <p:cNvPr id="24" name="TextBox 23"/>
+          <p:cNvSpPr txBox="1"/>
+          <p:nvPr/>
+        </p:nvSpPr>
+        <p:spPr>
+          <a:xfrm>
+            <a:off x="6355080" y="3794760"/>
+            <a:ext cx="4800600" cy="1600200"/>
+          </a:xfrm>
+          <a:prstGeom prst="rect">
+            <a:avLst/>
+          </a:prstGeom>
+          <a:noFill/>
+        </p:spPr>
+        <p:txBody>
+          <a:bodyPr wrap="square">
+            <a:spAutoFit/>
+          </a:bodyPr>
+          <a:lstStyle/>
+          <a:p>
+            <a:pPr algn="l"/>
+            <a:r>
+              <a:rPr sz="1400" b="0">
+                <a:solidFill>
+                  <a:srgbClr val="0F2038"/>
+                </a:solidFill>
+                <a:latin typeface="Aptos"/>
+              </a:rPr>
+              <a:t>Management asks</a:t>
+            </a:r>
+            <a:br/>
+            <a:r>
+              <a:rPr sz="1400" b="0">
+                <a:solidFill>
+                  <a:srgbClr val="0F2038"/>
+                </a:solidFill>
+                <a:latin typeface="Aptos"/>
+              </a:rPr>
+              <a:t>- Approve additional enterprise solution-engineering capacity.</a:t>
+            </a:r>
+            <a:br/>
+            <a:r>
+              <a:rPr sz="1400" b="0">
+                <a:solidFill>
+                  <a:srgbClr val="0F2038"/>
+                </a:solidFill>
+                <a:latin typeface="Aptos"/>
+              </a:rPr>
+              <a:t>- Keep Q2 discretionary spend gated by pipeline conversion.</a:t>
+            </a:r>
+            <a:br/>
+            <a:r>
+              <a:rPr sz="1400" b="0">
+                <a:solidFill>
+                  <a:srgbClr val="0F2038"/>
+                </a:solidFill>
+                <a:latin typeface="Aptos"/>
+              </a:rPr>
+              <a:t>- Revisit SMB packaging if churn remains above 2.5%.</a:t>
+            </a:r>
+          </a:p>
+        </p:txBody>
+      </p:sp>
+      <p:sp>
+        <p:nvSpPr>
+          <p:cNvPr id="25" name="TextBox 24"/>
+          <p:cNvSpPr txBox="1"/>
+          <p:nvPr/>
+        </p:nvSpPr>
+        <p:spPr>
+          <a:xfrm>
+            <a:off x="502920" y="6473952"/>
+            <a:ext cx="6400800" cy="201168"/>
+          </a:xfrm>
+          <a:prstGeom prst="rect">
+            <a:avLst/>
+          </a:prstGeom>
+          <a:noFill/>
+        </p:spPr>
+        <p:txBody>
+          <a:bodyPr wrap="square">
+            <a:spAutoFit/>
+          </a:bodyPr>
+          <a:lstStyle/>
+          <a:p>
+            <a:pPr algn="l"/>
+            <a:r>
+              <a:rPr sz="700" b="0">
+                <a:solidFill>
+                  <a:srgbClr val="64748B"/>
+                </a:solidFill>
+                <a:latin typeface="Aptos"/>
+              </a:rPr>
+              <a:t>Acme Growth Co. | Board Review Template | Q1 2026</a:t>
+            </a:r>
+          </a:p>
+        </p:txBody>
+      </p:sp>
+      <p:sp>
+        <p:nvSpPr>
+          <p:cNvPr id="26" name="TextBox 25"/>
+          <p:cNvSpPr txBox="1"/>
+          <p:nvPr/>
+        </p:nvSpPr>
+        <p:spPr>
+          <a:xfrm>
+            <a:off x="8503920" y="6473952"/>
+            <a:ext cx="2926080" cy="201168"/>
+          </a:xfrm>
+          <a:prstGeom prst="rect">
+            <a:avLst/>
+          </a:prstGeom>
+          <a:noFill/>
+        </p:spPr>
+        <p:txBody>
+          <a:bodyPr wrap="square">
+            <a:spAutoFit/>
+          </a:bodyPr>
+          <a:lstStyle/>
+          <a:p>
+            <a:pPr algn="r"/>
+            <a:r>
+              <a:rPr sz="700" b="0">
+                <a:solidFill>
+                  <a:srgbClr val="64748B"/>
+                </a:solidFill>
+                <a:latin typeface="Aptos"/>
+              </a:rPr>
+              <a:t>For internal planning discussion only</a:t>
+            </a:r>
+          </a:p>
+        </p:txBody>
+      </p:sp>
+    </p:spTree>
+  </p:cSld>
+  <p:clrMapOvr>
+    <a:masterClrMapping/>
+  </p:clrMapOvr>
+</p:sld>
+</file>
+
+<file path=ppt/slides/slide3.xml><?xml version="1.0" encoding="utf-8"?>
+<p:sld xmlns:a="http://schemas.openxmlformats.org/drawingml/2006/main" xmlns:p="http://schemas.openxmlformats.org/presentationml/2006/main" xmlns:r="http://schemas.openxmlformats.org/officeDocument/2006/relationships">
+  <p:cSld>
+    <p:spTree>
+      <p:nvGrpSpPr>
+        <p:cNvPr id="1" name=""/>
+        <p:cNvGrpSpPr/>
+        <p:nvPr/>
+      </p:nvGrpSpPr>
+      <p:grpSpPr/>
+      <p:sp>
+        <p:nvSpPr>
+          <p:cNvPr id="2" name="Rectangle 1"/>
+          <p:cNvSpPr/>
+          <p:nvPr/>
+        </p:nvSpPr>
+        <p:spPr>
+          <a:xfrm>
+            <a:off x="0" y="0"/>
+            <a:ext cx="12191695" cy="164592"/>
+          </a:xfrm>
+          <a:prstGeom prst="rect">
+            <a:avLst/>
+          </a:prstGeom>
+          <a:solidFill>
+            <a:srgbClr val="0057A4"/>
+          </a:solidFill>
+          <a:ln>
+            <a:noFill/>
+          </a:ln>
+        </p:spPr>
+        <p:style>
+          <a:lnRef idx="1">
+            <a:schemeClr val="accent1"/>
+          </a:lnRef>
+          <a:fillRef idx="3">
+            <a:schemeClr val="accent1"/>
+          </a:fillRef>
+          <a:effectRef idx="2">
+            <a:schemeClr val="accent1"/>
+          </a:effectRef>
+          <a:fontRef idx="minor">
+            <a:schemeClr val="lt1"/>
+          </a:fontRef>
+        </p:style>
+        <p:txBody>
+          <a:bodyPr rtlCol="0" anchor="ctr"/>
+          <a:lstStyle/>
+          <a:p>
+            <a:pPr algn="ctr"/>
+          </a:p>
+        </p:txBody>
+      </p:sp>
+      <p:sp>
+        <p:nvSpPr>
+          <p:cNvPr id="3" name="TextBox 2"/>
+          <p:cNvSpPr txBox="1"/>
+          <p:nvPr/>
+        </p:nvSpPr>
+        <p:spPr>
+          <a:xfrm>
+            <a:off x="502920" y="256032"/>
+            <a:ext cx="3108960" cy="228600"/>
+          </a:xfrm>
+          <a:prstGeom prst="rect">
+            <a:avLst/>
+          </a:prstGeom>
+          <a:noFill/>
+        </p:spPr>
+        <p:txBody>
+          <a:bodyPr wrap="square">
+            <a:spAutoFit/>
+          </a:bodyPr>
+          <a:lstStyle/>
+          <a:p>
+            <a:pPr algn="l"/>
+            <a:r>
+              <a:rPr sz="700" b="1">
+                <a:solidFill>
+                  <a:srgbClr val="64748B"/>
+                </a:solidFill>
+                <a:latin typeface="Aptos"/>
+              </a:rPr>
+              <a:t>CONFIDENTIAL BUSINESS REVIEW</a:t>
+            </a:r>
+          </a:p>
+        </p:txBody>
+      </p:sp>
+      <p:sp>
+        <p:nvSpPr>
+          <p:cNvPr id="4" name="TextBox 3"/>
+          <p:cNvSpPr txBox="1"/>
+          <p:nvPr/>
+        </p:nvSpPr>
+        <p:spPr>
+          <a:xfrm>
+            <a:off x="502920" y="530352"/>
+            <a:ext cx="8046720" cy="438912"/>
+          </a:xfrm>
+          <a:prstGeom prst="rect">
+            <a:avLst/>
+          </a:prstGeom>
+          <a:noFill/>
+        </p:spPr>
+        <p:txBody>
+          <a:bodyPr wrap="square">
+            <a:spAutoFit/>
+          </a:bodyPr>
+          <a:lstStyle/>
+          <a:p>
+            <a:pPr algn="l"/>
+            <a:r>
+              <a:rPr sz="2300" b="1">
+                <a:solidFill>
+                  <a:srgbClr val="0F2038"/>
+                </a:solidFill>
+                <a:latin typeface="Aptos"/>
+              </a:rPr>
+              <a:t>Revenue trend and forecast</a:t>
+            </a:r>
+          </a:p>
+        </p:txBody>
+      </p:sp>
+      <p:sp>
+        <p:nvSpPr>
+          <p:cNvPr id="5" name="TextBox 4"/>
+          <p:cNvSpPr txBox="1"/>
+          <p:nvPr/>
+        </p:nvSpPr>
+        <p:spPr>
+          <a:xfrm>
+            <a:off x="10378440" y="393192"/>
+            <a:ext cx="1234440" cy="320040"/>
+          </a:xfrm>
+          <a:prstGeom prst="rect">
+            <a:avLst/>
+          </a:prstGeom>
+          <a:solidFill>
+            <a:srgbClr val="F58220"/>
+          </a:solidFill>
+          <a:ln>
+            <a:noFill/>
+          </a:ln>
+        </p:spPr>
+        <p:txBody>
+          <a:bodyPr wrap="square">
+            <a:spAutoFit/>
+          </a:bodyPr>
+          <a:lstStyle/>
+          <a:p>
+            <a:pPr algn="ctr"/>
+            <a:r>
+              <a:rPr sz="1000" b="1">
+                <a:solidFill>
+                  <a:srgbClr val="FFFFFF"/>
+                </a:solidFill>
+                <a:latin typeface="Aptos"/>
+              </a:rPr>
+              <a:t>Q1 2026</a:t>
+            </a:r>
+          </a:p>
+        </p:txBody>
+      </p:sp>
+      <p:graphicFrame>
+        <p:nvGraphicFramePr>
+          <p:cNvPr id="6" name="Chart 5"/>
+          <p:cNvGraphicFramePr>
+            <a:graphicFrameLocks noGrp="1"/>
+          </p:cNvGraphicFramePr>
+          <p:nvPr/>
+        </p:nvGraphicFramePr>
+        <p:xfrm>
+          <a:off x="685800" y="1325880"/>
+          <a:ext cx="6629400" cy="3291840"/>
+        </p:xfrm>
+        <a:graphic>
+          <a:graphicData uri="http://schemas.openxmlformats.org/drawingml/2006/chart">
+            <c:chart xmlns:c="http://schemas.openxmlformats.org/drawingml/2006/chart" r:id="rId2"/>
+          </a:graphicData>
+        </a:graphic>
+      </p:graphicFrame>
+      <p:sp>
+        <p:nvSpPr>
+          <p:cNvPr id="7" name="TextBox 6"/>
+          <p:cNvSpPr txBox="1"/>
+          <p:nvPr/>
+        </p:nvSpPr>
+        <p:spPr>
+          <a:xfrm>
+            <a:off x="7635240" y="1417320"/>
+            <a:ext cx="3566160" cy="713232"/>
+          </a:xfrm>
+          <a:prstGeom prst="rect">
+            <a:avLst/>
+          </a:prstGeom>
+          <a:noFill/>
+        </p:spPr>
+        <p:txBody>
+          <a:bodyPr wrap="square">
+            <a:spAutoFit/>
+          </a:bodyPr>
+          <a:lstStyle/>
+          <a:p>
+            <a:pPr algn="l"/>
+            <a:r>
+              <a:rPr sz="1600" b="1">
+                <a:solidFill>
+                  <a:srgbClr val="0F2038"/>
+                </a:solidFill>
+                <a:latin typeface="Aptos"/>
+              </a:rPr>
+              <a:t>Q1 revenue closed at $12.4M, below the stretch case but ahead of the board-approved base plan.</a:t>
+            </a:r>
+          </a:p>
+        </p:txBody>
+      </p:sp>
+      <p:sp>
+        <p:nvSpPr>
+          <p:cNvPr id="8" name="TextBox 7"/>
+          <p:cNvSpPr txBox="1"/>
+          <p:nvPr/>
+        </p:nvSpPr>
+        <p:spPr>
+          <a:xfrm>
+            <a:off x="7635240" y="2468880"/>
+            <a:ext cx="3474720" cy="1691640"/>
+          </a:xfrm>
+          <a:prstGeom prst="rect">
+            <a:avLst/>
+          </a:prstGeom>
+          <a:noFill/>
+        </p:spPr>
+        <p:txBody>
+          <a:bodyPr wrap="square">
+            <a:spAutoFit/>
+          </a:bodyPr>
+          <a:lstStyle/>
+          <a:p>
+            <a:pPr algn="l"/>
+            <a:r>
+              <a:rPr sz="1300" b="0">
+                <a:solidFill>
+                  <a:srgbClr val="0F2038"/>
+                </a:solidFill>
+                <a:latin typeface="Aptos"/>
+              </a:rPr>
+              <a:t>Forecast notes</a:t>
+            </a:r>
+            <a:br/>
+            <a:r>
+              <a:rPr sz="1300" b="0">
+                <a:solidFill>
+                  <a:srgbClr val="0F2038"/>
+                </a:solidFill>
+                <a:latin typeface="Aptos"/>
+              </a:rPr>
+              <a:t>- March rebound came from two enterprise expansions.</a:t>
+            </a:r>
+            <a:br/>
+            <a:r>
+              <a:rPr sz="1300" b="0">
+                <a:solidFill>
+                  <a:srgbClr val="0F2038"/>
+                </a:solidFill>
+                <a:latin typeface="Aptos"/>
+              </a:rPr>
+              <a:t>- New logo conversion was slower than planned.</a:t>
+            </a:r>
+            <a:br/>
+            <a:r>
+              <a:rPr sz="1300" b="0">
+                <a:solidFill>
+                  <a:srgbClr val="0F2038"/>
+                </a:solidFill>
+                <a:latin typeface="Aptos"/>
+              </a:rPr>
+              <a:t>- Q2 forecast assumes no material price increase.</a:t>
+            </a:r>
+            <a:br/>
+            <a:r>
+              <a:rPr sz="1300" b="0">
+                <a:solidFill>
+                  <a:srgbClr val="0F2038"/>
+                </a:solidFill>
+                <a:latin typeface="Aptos"/>
+              </a:rPr>
+              <a:t>- Upside depends on healthcare and fintech pipeline.</a:t>
+            </a:r>
+          </a:p>
+        </p:txBody>
+      </p:sp>
+      <p:sp>
+        <p:nvSpPr>
+          <p:cNvPr id="9" name="TextBox 8"/>
+          <p:cNvSpPr txBox="1"/>
+          <p:nvPr/>
+        </p:nvSpPr>
+        <p:spPr>
+          <a:xfrm>
+            <a:off x="502920" y="6473952"/>
+            <a:ext cx="6400800" cy="201168"/>
+          </a:xfrm>
+          <a:prstGeom prst="rect">
+            <a:avLst/>
+          </a:prstGeom>
+          <a:noFill/>
+        </p:spPr>
+        <p:txBody>
+          <a:bodyPr wrap="square">
+            <a:spAutoFit/>
+          </a:bodyPr>
+          <a:lstStyle/>
+          <a:p>
+            <a:pPr algn="l"/>
+            <a:r>
+              <a:rPr sz="700" b="0">
+                <a:solidFill>
+                  <a:srgbClr val="64748B"/>
+                </a:solidFill>
+                <a:latin typeface="Aptos"/>
+              </a:rPr>
+              <a:t>Acme Growth Co. | Board Review Template | Q1 2026</a:t>
+            </a:r>
+          </a:p>
+        </p:txBody>
+      </p:sp>
+      <p:sp>
+        <p:nvSpPr>
+          <p:cNvPr id="10" name="TextBox 9"/>
+          <p:cNvSpPr txBox="1"/>
+          <p:nvPr/>
+        </p:nvSpPr>
+        <p:spPr>
+          <a:xfrm>
+            <a:off x="8503920" y="6473952"/>
+            <a:ext cx="2926080" cy="201168"/>
+          </a:xfrm>
+          <a:prstGeom prst="rect">
+            <a:avLst/>
+          </a:prstGeom>
+          <a:noFill/>
+        </p:spPr>
+        <p:txBody>
+          <a:bodyPr wrap="square">
+            <a:spAutoFit/>
+          </a:bodyPr>
+          <a:lstStyle/>
+          <a:p>
+            <a:pPr algn="r"/>
+            <a:r>
+              <a:rPr sz="700" b="0">
+                <a:solidFill>
+                  <a:srgbClr val="64748B"/>
+                </a:solidFill>
+                <a:latin typeface="Aptos"/>
+              </a:rPr>
+              <a:t>For internal planning discussion only</a:t>
+            </a:r>
+          </a:p>
+        </p:txBody>
+      </p:sp>
+    </p:spTree>
+  </p:cSld>
+  <p:clrMapOvr>
+    <a:masterClrMapping/>
+  </p:clrMapOvr>
+</p:sld>
+</file>
+
+<file path=ppt/slides/slide4.xml><?xml version="1.0" encoding="utf-8"?>
+<p:sld xmlns:a="http://schemas.openxmlformats.org/drawingml/2006/main" xmlns:p="http://schemas.openxmlformats.org/presentationml/2006/main" xmlns:r="http://schemas.openxmlformats.org/officeDocument/2006/relationships">
+  <p:cSld>
+    <p:spTree>
+      <p:nvGrpSpPr>
+        <p:cNvPr id="1" name=""/>
+        <p:cNvGrpSpPr/>
+        <p:nvPr/>
+      </p:nvGrpSpPr>
+      <p:grpSpPr/>
+      <p:sp>
+        <p:nvSpPr>
+          <p:cNvPr id="2" name="Rectangle 1"/>
+          <p:cNvSpPr/>
+          <p:nvPr/>
+        </p:nvSpPr>
+        <p:spPr>
+          <a:xfrm>
+            <a:off x="0" y="0"/>
+            <a:ext cx="12191695" cy="164592"/>
+          </a:xfrm>
+          <a:prstGeom prst="rect">
+            <a:avLst/>
+          </a:prstGeom>
+          <a:solidFill>
+            <a:srgbClr val="0057A4"/>
+          </a:solidFill>
+          <a:ln>
+            <a:noFill/>
+          </a:ln>
+        </p:spPr>
+        <p:style>
+          <a:lnRef idx="1">
+            <a:schemeClr val="accent1"/>
+          </a:lnRef>
+          <a:fillRef idx="3">
+            <a:schemeClr val="accent1"/>
+          </a:fillRef>
+          <a:effectRef idx="2">
+            <a:schemeClr val="accent1"/>
+          </a:effectRef>
+          <a:fontRef idx="minor">
+            <a:schemeClr val="lt1"/>
+          </a:fontRef>
+        </p:style>
+        <p:txBody>
+          <a:bodyPr rtlCol="0" anchor="ctr"/>
+          <a:lstStyle/>
+          <a:p>
+            <a:pPr algn="ctr"/>
+          </a:p>
+        </p:txBody>
+      </p:sp>
+      <p:sp>
+        <p:nvSpPr>
+          <p:cNvPr id="3" name="TextBox 2"/>
+          <p:cNvSpPr txBox="1"/>
+          <p:nvPr/>
+        </p:nvSpPr>
+        <p:spPr>
+          <a:xfrm>
+            <a:off x="502920" y="256032"/>
+            <a:ext cx="3108960" cy="228600"/>
+          </a:xfrm>
+          <a:prstGeom prst="rect">
+            <a:avLst/>
+          </a:prstGeom>
+          <a:noFill/>
+        </p:spPr>
+        <p:txBody>
+          <a:bodyPr wrap="square">
+            <a:spAutoFit/>
+          </a:bodyPr>
+          <a:lstStyle/>
+          <a:p>
+            <a:pPr algn="l"/>
+            <a:r>
+              <a:rPr sz="700" b="1">
+                <a:solidFill>
+                  <a:srgbClr val="64748B"/>
+                </a:solidFill>
+                <a:latin typeface="Aptos"/>
+              </a:rPr>
+              <a:t>CONFIDENTIAL BUSINESS REVIEW</a:t>
+            </a:r>
+          </a:p>
+        </p:txBody>
+      </p:sp>
+      <p:sp>
+        <p:nvSpPr>
+          <p:cNvPr id="4" name="TextBox 3"/>
+          <p:cNvSpPr txBox="1"/>
+          <p:nvPr/>
+        </p:nvSpPr>
+        <p:spPr>
+          <a:xfrm>
+            <a:off x="502920" y="530352"/>
+            <a:ext cx="8046720" cy="438912"/>
+          </a:xfrm>
+          <a:prstGeom prst="rect">
+            <a:avLst/>
+          </a:prstGeom>
+          <a:noFill/>
+        </p:spPr>
+        <p:txBody>
+          <a:bodyPr wrap="square">
+            <a:spAutoFit/>
+          </a:bodyPr>
+          <a:lstStyle/>
+          <a:p>
+            <a:pPr algn="l"/>
+            <a:r>
+              <a:rPr sz="2300" b="1">
+                <a:solidFill>
+                  <a:srgbClr val="0F2038"/>
+                </a:solidFill>
+                <a:latin typeface="Aptos"/>
+              </a:rPr>
+              <a:t>Segment performance</a:t>
+            </a:r>
+          </a:p>
+        </p:txBody>
+      </p:sp>
+      <p:sp>
+        <p:nvSpPr>
+          <p:cNvPr id="5" name="TextBox 4"/>
+          <p:cNvSpPr txBox="1"/>
+          <p:nvPr/>
+        </p:nvSpPr>
+        <p:spPr>
+          <a:xfrm>
+            <a:off x="10378440" y="393192"/>
+            <a:ext cx="1234440" cy="320040"/>
+          </a:xfrm>
+          <a:prstGeom prst="rect">
+            <a:avLst/>
+          </a:prstGeom>
+          <a:solidFill>
+            <a:srgbClr val="F58220"/>
+          </a:solidFill>
+          <a:ln>
+            <a:noFill/>
+          </a:ln>
+        </p:spPr>
+        <p:txBody>
+          <a:bodyPr wrap="square">
+            <a:spAutoFit/>
+          </a:bodyPr>
+          <a:lstStyle/>
+          <a:p>
+            <a:pPr algn="ctr"/>
+            <a:r>
+              <a:rPr sz="1000" b="1">
+                <a:solidFill>
+                  <a:srgbClr val="FFFFFF"/>
+                </a:solidFill>
+                <a:latin typeface="Aptos"/>
+              </a:rPr>
+              <a:t>Q1 2026</a:t>
+            </a:r>
+          </a:p>
+        </p:txBody>
+      </p:sp>
+      <p:graphicFrame>
+        <p:nvGraphicFramePr>
+          <p:cNvPr id="6" name="Table 5"/>
+          <p:cNvGraphicFramePr>
+            <a:graphicFrameLocks noGrp="1"/>
+          </p:cNvGraphicFramePr>
+          <p:nvPr/>
+        </p:nvGraphicFramePr>
+        <p:xfrm>
+          <a:off x="685800" y="1325880"/>
+          <a:ext cx="10789920" cy="2423160"/>
+        </p:xfrm>
+        <a:graphic>
+          <a:graphicData uri="http://schemas.openxmlformats.org/drawingml/2006/table">
+            <a:tbl>
+              <a:tblPr firstRow="1" bandRow="1">
+                <a:tableStyleId>{5C22544A-7EE6-4342-B048-85BDC9FD1C3A}</a:tableStyleId>
+              </a:tblPr>
+              <a:tblGrid>
+                <a:gridCol w="2157984"/>
+                <a:gridCol w="2157984"/>
+                <a:gridCol w="2157984"/>
+                <a:gridCol w="2157984"/>
+                <a:gridCol w="2157984"/>
+              </a:tblGrid>
+              <a:tr h="484632">
+                <a:tc>
+                  <a:txBody>
+                    <a:bodyPr/>
+                    <a:lstStyle/>
+                    <a:p>
+                      <a:r>
+                        <a:rPr sz="800" b="1">
+                          <a:solidFill>
+                            <a:srgbClr val="FFFFFF"/>
+                          </a:solidFill>
+                          <a:latin typeface="Aptos"/>
+                        </a:rPr>
+                        <a:t>Segment</a:t>
+                      </a:r>
+                    </a:p>
+                  </a:txBody>
+                  <a:tcPr marL="45720">
+                    <a:solidFill>
+                      <a:srgbClr val="0057A4"/>
+                    </a:solidFill>
+                  </a:tcPr>
+                </a:tc>
+                <a:tc>
+                  <a:txBody>
+                    <a:bodyPr/>
+                    <a:lstStyle/>
+                    <a:p>
+                      <a:r>
+                        <a:rPr sz="800" b="1">
+                          <a:solidFill>
+                            <a:srgbClr val="FFFFFF"/>
+                          </a:solidFill>
+                          <a:latin typeface="Aptos"/>
+                        </a:rPr>
+                        <a:t>Q1 Revenue</a:t>
+                      </a:r>
+                    </a:p>
+                  </a:txBody>
+                  <a:tcPr marL="45720">
+                    <a:solidFill>
+                      <a:srgbClr val="0057A4"/>
+                    </a:solidFill>
+                  </a:tcPr>
+                </a:tc>
+                <a:tc>
+                  <a:txBody>
+                    <a:bodyPr/>
+                    <a:lstStyle/>
+                    <a:p>
+                      <a:r>
+                        <a:rPr sz="800" b="1">
+                          <a:solidFill>
+                            <a:srgbClr val="FFFFFF"/>
+                          </a:solidFill>
+                          <a:latin typeface="Aptos"/>
+                        </a:rPr>
+                        <a:t>QoQ Growth</a:t>
+                      </a:r>
+                    </a:p>
+                  </a:txBody>
+                  <a:tcPr marL="45720">
+                    <a:solidFill>
+                      <a:srgbClr val="0057A4"/>
+                    </a:solidFill>
+                  </a:tcPr>
+                </a:tc>
+                <a:tc>
+                  <a:txBody>
+                    <a:bodyPr/>
+                    <a:lstStyle/>
+                    <a:p>
+                      <a:r>
+                        <a:rPr sz="800" b="1">
+                          <a:solidFill>
+                            <a:srgbClr val="FFFFFF"/>
+                          </a:solidFill>
+                          <a:latin typeface="Aptos"/>
+                        </a:rPr>
+                        <a:t>Gross Margin</a:t>
+                      </a:r>
+                    </a:p>
+                  </a:txBody>
+                  <a:tcPr marL="45720">
+                    <a:solidFill>
+                      <a:srgbClr val="0057A4"/>
+                    </a:solidFill>
+                  </a:tcPr>
+                </a:tc>
+                <a:tc>
+                  <a:txBody>
+                    <a:bodyPr/>
+                    <a:lstStyle/>
+                    <a:p>
+                      <a:r>
+                        <a:rPr sz="800" b="1">
+                          <a:solidFill>
+                            <a:srgbClr val="FFFFFF"/>
+                          </a:solidFill>
+                          <a:latin typeface="Aptos"/>
+                        </a:rPr>
+                        <a:t>Commentary</a:t>
+                      </a:r>
+                    </a:p>
+                  </a:txBody>
+                  <a:tcPr marL="45720">
+                    <a:solidFill>
+                      <a:srgbClr val="0057A4"/>
+                    </a:solidFill>
+                  </a:tcPr>
+                </a:tc>
+              </a:tr>
+              <a:tr h="484632">
+                <a:tc>
+                  <a:txBody>
+                    <a:bodyPr/>
+                    <a:lstStyle/>
+                    <a:p>
+                      <a:r>
+                        <a:rPr sz="900" b="1">
+                          <a:solidFill>
+                            <a:srgbClr val="0F2038"/>
+                          </a:solidFill>
+                          <a:latin typeface="Aptos"/>
+                        </a:rPr>
+                        <a:t>Enterprise</a:t>
+                      </a:r>
+                    </a:p>
+                  </a:txBody>
+                  <a:tcPr marL="45720"/>
+                </a:tc>
+                <a:tc>
+                  <a:txBody>
+                    <a:bodyPr/>
+                    <a:lstStyle/>
+                    <a:p>
+                      <a:r>
+                        <a:rPr sz="900" b="0">
+                          <a:solidFill>
+                            <a:srgbClr val="0F2038"/>
+                          </a:solidFill>
+                          <a:latin typeface="Aptos"/>
+                        </a:rPr>
+                        <a:t>$6.8M</a:t>
+                      </a:r>
+                    </a:p>
+                  </a:txBody>
+                  <a:tcPr marL="45720"/>
+                </a:tc>
+                <a:tc>
+                  <a:txBody>
+                    <a:bodyPr/>
+                    <a:lstStyle/>
+                    <a:p>
+                      <a:r>
+                        <a:rPr sz="900" b="0">
+                          <a:solidFill>
+                            <a:srgbClr val="0F2038"/>
+                          </a:solidFill>
+                          <a:latin typeface="Aptos"/>
+                        </a:rPr>
+                        <a:t>+14%</a:t>
+                      </a:r>
+                    </a:p>
+                  </a:txBody>
+                  <a:tcPr marL="45720"/>
+                </a:tc>
+                <a:tc>
+                  <a:txBody>
+                    <a:bodyPr/>
+                    <a:lstStyle/>
+                    <a:p>
+                      <a:r>
+                        <a:rPr sz="900" b="0">
+                          <a:solidFill>
+                            <a:srgbClr val="0F2038"/>
+                          </a:solidFill>
+                          <a:latin typeface="Aptos"/>
+                        </a:rPr>
+                        <a:t>71%</a:t>
+                      </a:r>
+                    </a:p>
+                  </a:txBody>
+                  <a:tcPr marL="45720"/>
+                </a:tc>
+                <a:tc>
+                  <a:txBody>
+                    <a:bodyPr/>
+                    <a:lstStyle/>
+                    <a:p>
+                      <a:r>
+                        <a:rPr sz="900" b="0">
+                          <a:solidFill>
+                            <a:srgbClr val="0F2038"/>
+                          </a:solidFill>
+                          <a:latin typeface="Aptos"/>
+                        </a:rPr>
+                        <a:t>Expansion-led growth</a:t>
+                      </a:r>
+                    </a:p>
+                  </a:txBody>
+                  <a:tcPr marL="45720"/>
+                </a:tc>
+              </a:tr>
+              <a:tr h="484632">
+                <a:tc>
+                  <a:txBody>
+                    <a:bodyPr/>
+                    <a:lstStyle/>
+                    <a:p>
+                      <a:r>
+                        <a:rPr sz="900" b="1">
+                          <a:solidFill>
+                            <a:srgbClr val="0F2038"/>
+                          </a:solidFill>
+                          <a:latin typeface="Aptos"/>
+                        </a:rPr>
+                        <a:t>Mid-market</a:t>
+                      </a:r>
+                    </a:p>
+                  </a:txBody>
+                  <a:tcPr marL="45720"/>
+                </a:tc>
+                <a:tc>
+                  <a:txBody>
+                    <a:bodyPr/>
+                    <a:lstStyle/>
+                    <a:p>
+                      <a:r>
+                        <a:rPr sz="900" b="0">
+                          <a:solidFill>
+                            <a:srgbClr val="0F2038"/>
+                          </a:solidFill>
+                          <a:latin typeface="Aptos"/>
+                        </a:rPr>
+                        <a:t>$3.7M</a:t>
+                      </a:r>
+                    </a:p>
+                  </a:txBody>
+                  <a:tcPr marL="45720"/>
+                </a:tc>
+                <a:tc>
+                  <a:txBody>
+                    <a:bodyPr/>
+                    <a:lstStyle/>
+                    <a:p>
+                      <a:r>
+                        <a:rPr sz="900" b="0">
+                          <a:solidFill>
+                            <a:srgbClr val="0F2038"/>
+                          </a:solidFill>
+                          <a:latin typeface="Aptos"/>
+                        </a:rPr>
+                        <a:t>+6%</a:t>
+                      </a:r>
+                    </a:p>
+                  </a:txBody>
+                  <a:tcPr marL="45720"/>
+                </a:tc>
+                <a:tc>
+                  <a:txBody>
+                    <a:bodyPr/>
+                    <a:lstStyle/>
+                    <a:p>
+                      <a:r>
+                        <a:rPr sz="900" b="0">
+                          <a:solidFill>
+                            <a:srgbClr val="0F2038"/>
+                          </a:solidFill>
+                          <a:latin typeface="Aptos"/>
+                        </a:rPr>
+                        <a:t>63%</a:t>
+                      </a:r>
+                    </a:p>
+                  </a:txBody>
+                  <a:tcPr marL="45720"/>
+                </a:tc>
+                <a:tc>
+                  <a:txBody>
+                    <a:bodyPr/>
+                    <a:lstStyle/>
+                    <a:p>
+                      <a:r>
+                        <a:rPr sz="900" b="0">
+                          <a:solidFill>
+                            <a:srgbClr val="0F2038"/>
+                          </a:solidFill>
+                          <a:latin typeface="Aptos"/>
+                        </a:rPr>
+                        <a:t>Stable demand</a:t>
+                      </a:r>
+                    </a:p>
+                  </a:txBody>
+                  <a:tcPr marL="45720"/>
+                </a:tc>
+              </a:tr>
+              <a:tr h="484632">
+                <a:tc>
+                  <a:txBody>
+                    <a:bodyPr/>
+                    <a:lstStyle/>
+                    <a:p>
+                      <a:r>
+                        <a:rPr sz="900" b="1">
+                          <a:solidFill>
+                            <a:srgbClr val="0F2038"/>
+                          </a:solidFill>
+                          <a:latin typeface="Aptos"/>
+                        </a:rPr>
+                        <a:t>SMB</a:t>
+                      </a:r>
+                    </a:p>
+                  </a:txBody>
+                  <a:tcPr marL="45720"/>
+                </a:tc>
+                <a:tc>
+                  <a:txBody>
+                    <a:bodyPr/>
+                    <a:lstStyle/>
+                    <a:p>
+                      <a:r>
+                        <a:rPr sz="900" b="0">
+                          <a:solidFill>
+                            <a:srgbClr val="0F2038"/>
+                          </a:solidFill>
+                          <a:latin typeface="Aptos"/>
+                        </a:rPr>
+                        <a:t>$1.9M</a:t>
+                      </a:r>
+                    </a:p>
+                  </a:txBody>
+                  <a:tcPr marL="45720"/>
+                </a:tc>
+                <a:tc>
+                  <a:txBody>
+                    <a:bodyPr/>
+                    <a:lstStyle/>
+                    <a:p>
+                      <a:r>
+                        <a:rPr sz="900" b="0">
+                          <a:solidFill>
+                            <a:srgbClr val="0F2038"/>
+                          </a:solidFill>
+                          <a:latin typeface="Aptos"/>
+                        </a:rPr>
+                        <a:t>-3%</a:t>
+                      </a:r>
+                    </a:p>
+                  </a:txBody>
+                  <a:tcPr marL="45720"/>
+                </a:tc>
+                <a:tc>
+                  <a:txBody>
+                    <a:bodyPr/>
+                    <a:lstStyle/>
+                    <a:p>
+                      <a:r>
+                        <a:rPr sz="900" b="0">
+                          <a:solidFill>
+                            <a:srgbClr val="0F2038"/>
+                          </a:solidFill>
+                          <a:latin typeface="Aptos"/>
+                        </a:rPr>
+                        <a:t>49%</a:t>
+                      </a:r>
+                    </a:p>
+                  </a:txBody>
+                  <a:tcPr marL="45720"/>
+                </a:tc>
+                <a:tc>
+                  <a:txBody>
+                    <a:bodyPr/>
+                    <a:lstStyle/>
+                    <a:p>
+                      <a:r>
+                        <a:rPr sz="900" b="0">
+                          <a:solidFill>
+                            <a:srgbClr val="0F2038"/>
+                          </a:solidFill>
+                          <a:latin typeface="Aptos"/>
+                        </a:rPr>
+                        <a:t>Churn pressure</a:t>
+                      </a:r>
+                    </a:p>
+                  </a:txBody>
+                  <a:tcPr marL="45720"/>
+                </a:tc>
+              </a:tr>
+              <a:tr h="484632">
+                <a:tc>
+                  <a:txBody>
+                    <a:bodyPr/>
+                    <a:lstStyle/>
+                    <a:p>
+                      <a:r>
+                        <a:rPr sz="900" b="1">
+                          <a:solidFill>
+                            <a:srgbClr val="0F2038"/>
+                          </a:solidFill>
+                          <a:latin typeface="Aptos"/>
+                        </a:rPr>
+                        <a:t>Total</a:t>
+                      </a:r>
+                    </a:p>
+                  </a:txBody>
+                  <a:tcPr marL="45720"/>
+                </a:tc>
+                <a:tc>
+                  <a:txBody>
+                    <a:bodyPr/>
+                    <a:lstStyle/>
+                    <a:p>
+                      <a:r>
+                        <a:rPr sz="900" b="0">
+                          <a:solidFill>
+                            <a:srgbClr val="0F2038"/>
+                          </a:solidFill>
+                          <a:latin typeface="Aptos"/>
+                        </a:rPr>
+                        <a:t>$12.4M</a:t>
+                      </a:r>
+                    </a:p>
+                  </a:txBody>
+                  <a:tcPr marL="45720"/>
+                </a:tc>
+                <a:tc>
+                  <a:txBody>
+                    <a:bodyPr/>
+                    <a:lstStyle/>
+                    <a:p>
+                      <a:r>
+                        <a:rPr sz="900" b="0">
+                          <a:solidFill>
+                            <a:srgbClr val="0F2038"/>
+                          </a:solidFill>
+                          <a:latin typeface="Aptos"/>
+                        </a:rPr>
+                        <a:t>+8%</a:t>
+                      </a:r>
+                    </a:p>
+                  </a:txBody>
+                  <a:tcPr marL="45720"/>
+                </a:tc>
+                <a:tc>
+                  <a:txBody>
+                    <a:bodyPr/>
+                    <a:lstStyle/>
+                    <a:p>
+                      <a:r>
+                        <a:rPr sz="900" b="0">
+                          <a:solidFill>
+                            <a:srgbClr val="0F2038"/>
+                          </a:solidFill>
+                          <a:latin typeface="Aptos"/>
+                        </a:rPr>
+                        <a:t>64%</a:t>
+                      </a:r>
+                    </a:p>
+                  </a:txBody>
+                  <a:tcPr marL="45720"/>
+                </a:tc>
+                <a:tc>
+                  <a:txBody>
+                    <a:bodyPr/>
+                    <a:lstStyle/>
+                    <a:p>
+                      <a:r>
+                        <a:rPr sz="900" b="0">
+                          <a:solidFill>
+                            <a:srgbClr val="0F2038"/>
+                          </a:solidFill>
+                          <a:latin typeface="Aptos"/>
+                        </a:rPr>
+                        <a:t>Mixed but improving</a:t>
+                      </a:r>
+                    </a:p>
+                  </a:txBody>
+                  <a:tcPr marL="45720"/>
+                </a:tc>
+              </a:tr>
+            </a:tbl>
+          </a:graphicData>
+        </a:graphic>
+      </p:graphicFrame>
+      <p:sp>
+        <p:nvSpPr>
+          <p:cNvPr id="7" name="TextBox 6"/>
+          <p:cNvSpPr txBox="1"/>
+          <p:nvPr/>
+        </p:nvSpPr>
+        <p:spPr>
+          <a:xfrm>
+            <a:off x="777240" y="4206240"/>
+            <a:ext cx="7863840" cy="411480"/>
+          </a:xfrm>
+          <a:prstGeom prst="rect">
+            <a:avLst/>
+          </a:prstGeom>
+          <a:noFill/>
+        </p:spPr>
+        <p:txBody>
+          <a:bodyPr wrap="square">
+            <a:spAutoFit/>
+          </a:bodyPr>
+          <a:lstStyle/>
+          <a:p>
+            <a:pPr algn="l"/>
+            <a:r>
+              <a:rPr sz="1600" b="1">
+                <a:solidFill>
+                  <a:srgbClr val="0F2038"/>
+                </a:solidFill>
+                <a:latin typeface="Aptos"/>
+              </a:rPr>
+              <a:t>Q1 segment readout showed enterprise quality improving while SMB economics remained below threshold.</a:t>
+            </a:r>
+          </a:p>
+        </p:txBody>
+      </p:sp>
+      <p:sp>
+        <p:nvSpPr>
+          <p:cNvPr id="8" name="TextBox 7"/>
+          <p:cNvSpPr txBox="1"/>
+          <p:nvPr/>
+        </p:nvSpPr>
+        <p:spPr>
+          <a:xfrm>
+            <a:off x="777240" y="4709160"/>
+            <a:ext cx="7863840" cy="320040"/>
+          </a:xfrm>
+          <a:prstGeom prst="rect">
+            <a:avLst/>
+          </a:prstGeom>
+          <a:noFill/>
+        </p:spPr>
+        <p:txBody>
+          <a:bodyPr wrap="square">
+            <a:spAutoFit/>
+          </a:bodyPr>
+          <a:lstStyle/>
+          <a:p>
+            <a:pPr algn="l"/>
+            <a:r>
+              <a:rPr sz="1200" b="0">
+                <a:solidFill>
+                  <a:srgbClr val="64748B"/>
+                </a:solidFill>
+                <a:latin typeface="Aptos"/>
+              </a:rPr>
+              <a:t>Decision lens: prioritize segments with durable margin expansion and lower support burden.</a:t>
+            </a:r>
+          </a:p>
+        </p:txBody>
+      </p:sp>
+      <p:sp>
+        <p:nvSpPr>
+          <p:cNvPr id="9" name="TextBox 8"/>
+          <p:cNvSpPr txBox="1"/>
+          <p:nvPr/>
+        </p:nvSpPr>
+        <p:spPr>
+          <a:xfrm>
+            <a:off x="502920" y="6473952"/>
+            <a:ext cx="6400800" cy="201168"/>
+          </a:xfrm>
+          <a:prstGeom prst="rect">
+            <a:avLst/>
+          </a:prstGeom>
+          <a:noFill/>
+        </p:spPr>
+        <p:txBody>
+          <a:bodyPr wrap="square">
+            <a:spAutoFit/>
+          </a:bodyPr>
+          <a:lstStyle/>
+          <a:p>
+            <a:pPr algn="l"/>
+            <a:r>
+              <a:rPr sz="700" b="0">
+                <a:solidFill>
+                  <a:srgbClr val="64748B"/>
+                </a:solidFill>
+                <a:latin typeface="Aptos"/>
+              </a:rPr>
+              <a:t>Acme Growth Co. | Board Review Template | Q1 2026</a:t>
+            </a:r>
+          </a:p>
+        </p:txBody>
+      </p:sp>
+      <p:sp>
+        <p:nvSpPr>
+          <p:cNvPr id="10" name="TextBox 9"/>
+          <p:cNvSpPr txBox="1"/>
+          <p:nvPr/>
+        </p:nvSpPr>
+        <p:spPr>
+          <a:xfrm>
+            <a:off x="8503920" y="6473952"/>
+            <a:ext cx="2926080" cy="201168"/>
+          </a:xfrm>
+          <a:prstGeom prst="rect">
+            <a:avLst/>
+          </a:prstGeom>
+          <a:noFill/>
+        </p:spPr>
+        <p:txBody>
+          <a:bodyPr wrap="square">
+            <a:spAutoFit/>
+          </a:bodyPr>
+          <a:lstStyle/>
+          <a:p>
+            <a:pPr algn="r"/>
+            <a:r>
+              <a:rPr sz="700" b="0">
+                <a:solidFill>
+                  <a:srgbClr val="64748B"/>
+                </a:solidFill>
+                <a:latin typeface="Aptos"/>
+              </a:rPr>
+              <a:t>For internal planning discussion only</a:t>
+            </a:r>
+          </a:p>
+        </p:txBody>
+      </p:sp>
+    </p:spTree>
+  </p:cSld>
+  <p:clrMapOvr>
+    <a:masterClrMapping/>
+  </p:clrMapOvr>
+</p:sld>
+</file>
+
+<file path=ppt/slides/slide5.xml><?xml version="1.0" encoding="utf-8"?>
+<p:sld xmlns:a="http://schemas.openxmlformats.org/drawingml/2006/main" xmlns:p="http://schemas.openxmlformats.org/presentationml/2006/main" xmlns:r="http://schemas.openxmlformats.org/officeDocument/2006/relationships">
+  <p:cSld>
+    <p:spTree>
+      <p:nvGrpSpPr>
+        <p:cNvPr id="1" name=""/>
+        <p:cNvGrpSpPr/>
+        <p:nvPr/>
+      </p:nvGrpSpPr>
+      <p:grpSpPr/>
+      <p:sp>
+        <p:nvSpPr>
+          <p:cNvPr id="2" name="Rectangle 1"/>
+          <p:cNvSpPr/>
+          <p:nvPr/>
+        </p:nvSpPr>
+        <p:spPr>
+          <a:xfrm>
+            <a:off x="0" y="0"/>
+            <a:ext cx="12191695" cy="164592"/>
+          </a:xfrm>
+          <a:prstGeom prst="rect">
+            <a:avLst/>
+          </a:prstGeom>
+          <a:solidFill>
+            <a:srgbClr val="0057A4"/>
+          </a:solidFill>
+          <a:ln>
+            <a:noFill/>
+          </a:ln>
+        </p:spPr>
+        <p:style>
+          <a:lnRef idx="1">
+            <a:schemeClr val="accent1"/>
+          </a:lnRef>
+          <a:fillRef idx="3">
+            <a:schemeClr val="accent1"/>
+          </a:fillRef>
+          <a:effectRef idx="2">
+            <a:schemeClr val="accent1"/>
+          </a:effectRef>
+          <a:fontRef idx="minor">
+            <a:schemeClr val="lt1"/>
+          </a:fontRef>
+        </p:style>
+        <p:txBody>
+          <a:bodyPr rtlCol="0" anchor="ctr"/>
+          <a:lstStyle/>
+          <a:p>
+            <a:pPr algn="ctr"/>
+          </a:p>
+        </p:txBody>
+      </p:sp>
+      <p:sp>
+        <p:nvSpPr>
+          <p:cNvPr id="3" name="TextBox 2"/>
+          <p:cNvSpPr txBox="1"/>
+          <p:nvPr/>
+        </p:nvSpPr>
+        <p:spPr>
+          <a:xfrm>
+            <a:off x="502920" y="256032"/>
+            <a:ext cx="3108960" cy="228600"/>
+          </a:xfrm>
+          <a:prstGeom prst="rect">
+            <a:avLst/>
+          </a:prstGeom>
+          <a:noFill/>
+        </p:spPr>
+        <p:txBody>
+          <a:bodyPr wrap="square">
+            <a:spAutoFit/>
+          </a:bodyPr>
+          <a:lstStyle/>
+          <a:p>
+            <a:pPr algn="l"/>
+            <a:r>
+              <a:rPr sz="700" b="1">
+                <a:solidFill>
+                  <a:srgbClr val="64748B"/>
+                </a:solidFill>
+                <a:latin typeface="Aptos"/>
+              </a:rPr>
+              <a:t>CONFIDENTIAL BUSINESS REVIEW</a:t>
+            </a:r>
+          </a:p>
+        </p:txBody>
+      </p:sp>
+      <p:sp>
+        <p:nvSpPr>
+          <p:cNvPr id="4" name="TextBox 3"/>
+          <p:cNvSpPr txBox="1"/>
+          <p:nvPr/>
+        </p:nvSpPr>
+        <p:spPr>
+          <a:xfrm>
+            <a:off x="502920" y="530352"/>
+            <a:ext cx="8046720" cy="438912"/>
+          </a:xfrm>
+          <a:prstGeom prst="rect">
+            <a:avLst/>
+          </a:prstGeom>
+          <a:noFill/>
+        </p:spPr>
+        <p:txBody>
+          <a:bodyPr wrap="square">
+            <a:spAutoFit/>
+          </a:bodyPr>
+          <a:lstStyle/>
+          <a:p>
+            <a:pPr algn="l"/>
+            <a:r>
+              <a:rPr sz="2300" b="1">
+                <a:solidFill>
+                  <a:srgbClr val="0F2038"/>
+                </a:solidFill>
+                <a:latin typeface="Aptos"/>
+              </a:rPr>
+              <a:t>Risks, mitigations, and operating watchlist</a:t>
+            </a:r>
+          </a:p>
+        </p:txBody>
+      </p:sp>
+      <p:sp>
+        <p:nvSpPr>
+          <p:cNvPr id="5" name="TextBox 4"/>
+          <p:cNvSpPr txBox="1"/>
+          <p:nvPr/>
+        </p:nvSpPr>
+        <p:spPr>
+          <a:xfrm>
+            <a:off x="10378440" y="393192"/>
+            <a:ext cx="1234440" cy="320040"/>
+          </a:xfrm>
+          <a:prstGeom prst="rect">
+            <a:avLst/>
+          </a:prstGeom>
+          <a:solidFill>
+            <a:srgbClr val="F58220"/>
+          </a:solidFill>
+          <a:ln>
+            <a:noFill/>
+          </a:ln>
+        </p:spPr>
+        <p:txBody>
+          <a:bodyPr wrap="square">
+            <a:spAutoFit/>
+          </a:bodyPr>
+          <a:lstStyle/>
+          <a:p>
+            <a:pPr algn="ctr"/>
+            <a:r>
+              <a:rPr sz="1000" b="1">
+                <a:solidFill>
+                  <a:srgbClr val="FFFFFF"/>
+                </a:solidFill>
+                <a:latin typeface="Aptos"/>
+              </a:rPr>
+              <a:t>Q1 2026</a:t>
+            </a:r>
+          </a:p>
+        </p:txBody>
+      </p:sp>
+      <p:sp>
+        <p:nvSpPr>
+          <p:cNvPr id="6" name="TextBox 5"/>
+          <p:cNvSpPr txBox="1"/>
+          <p:nvPr/>
+        </p:nvSpPr>
+        <p:spPr>
+          <a:xfrm>
+            <a:off x="685800" y="1234440"/>
+            <a:ext cx="9875520" cy="457200"/>
+          </a:xfrm>
+          <a:prstGeom prst="rect">
+            <a:avLst/>
+          </a:prstGeom>
+          <a:noFill/>
+        </p:spPr>
+        <p:txBody>
+          <a:bodyPr wrap="square">
+            <a:spAutoFit/>
+          </a:bodyPr>
+          <a:lstStyle/>
+          <a:p>
+            <a:pPr algn="l"/>
+            <a:r>
+              <a:rPr sz="1700" b="1">
+                <a:solidFill>
+                  <a:srgbClr val="0F2038"/>
+                </a:solidFill>
+                <a:latin typeface="Aptos"/>
+              </a:rPr>
+              <a:t>Q1 risk posture remained manageable, with customer concentration and SMB churn requiring continued attention.</a:t>
+            </a:r>
+          </a:p>
+        </p:txBody>
+      </p:sp>
+      <p:sp>
+        <p:nvSpPr>
+          <p:cNvPr id="7" name="TextBox 6"/>
+          <p:cNvSpPr txBox="1"/>
+          <p:nvPr/>
+        </p:nvSpPr>
+        <p:spPr>
+          <a:xfrm>
+            <a:off x="777240" y="1965960"/>
+            <a:ext cx="5120640" cy="1554480"/>
+          </a:xfrm>
+          <a:prstGeom prst="rect">
+            <a:avLst/>
+          </a:prstGeom>
+          <a:noFill/>
+        </p:spPr>
+        <p:txBody>
+          <a:bodyPr wrap="square">
+            <a:spAutoFit/>
+          </a:bodyPr>
+          <a:lstStyle/>
+          <a:p>
+            <a:pPr algn="l"/>
+            <a:r>
+              <a:rPr sz="1400" b="0">
+                <a:solidFill>
+                  <a:srgbClr val="0F2038"/>
+                </a:solidFill>
+                <a:latin typeface="Aptos"/>
+              </a:rPr>
+              <a:t>Risk register</a:t>
+            </a:r>
+            <a:br/>
+            <a:r>
+              <a:rPr sz="1400" b="0">
+                <a:solidFill>
+                  <a:srgbClr val="0F2038"/>
+                </a:solidFill>
+                <a:latin typeface="Aptos"/>
+              </a:rPr>
+              <a:t>- Enterprise deals are concentrated in 6 named accounts.</a:t>
+            </a:r>
+            <a:br/>
+            <a:r>
+              <a:rPr sz="1400" b="0">
+                <a:solidFill>
+                  <a:srgbClr val="0F2038"/>
+                </a:solidFill>
+                <a:latin typeface="Aptos"/>
+              </a:rPr>
+              <a:t>- SMB churn may offset self-serve acquisition gains.</a:t>
+            </a:r>
+            <a:br/>
+            <a:r>
+              <a:rPr sz="1400" b="0">
+                <a:solidFill>
+                  <a:srgbClr val="0F2038"/>
+                </a:solidFill>
+                <a:latin typeface="Aptos"/>
+              </a:rPr>
+              <a:t>- Cloud infrastructure cost could rise with AI usage.</a:t>
+            </a:r>
+            <a:br/>
+            <a:r>
+              <a:rPr sz="1400" b="0">
+                <a:solidFill>
+                  <a:srgbClr val="0F2038"/>
+                </a:solidFill>
+                <a:latin typeface="Aptos"/>
+              </a:rPr>
+              <a:t>- Hiring delays may constrain implementation capacity.</a:t>
+            </a:r>
+          </a:p>
+        </p:txBody>
+      </p:sp>
+      <p:sp>
+        <p:nvSpPr>
+          <p:cNvPr id="8" name="TextBox 7"/>
+          <p:cNvSpPr txBox="1"/>
+          <p:nvPr/>
+        </p:nvSpPr>
+        <p:spPr>
+          <a:xfrm>
+            <a:off x="6263640" y="1965960"/>
+            <a:ext cx="5029200" cy="1554480"/>
+          </a:xfrm>
+          <a:prstGeom prst="rect">
+            <a:avLst/>
+          </a:prstGeom>
+          <a:noFill/>
+        </p:spPr>
+        <p:txBody>
+          <a:bodyPr wrap="square">
+            <a:spAutoFit/>
+          </a:bodyPr>
+          <a:lstStyle/>
+          <a:p>
+            <a:pPr algn="l"/>
+            <a:r>
+              <a:rPr sz="1400" b="0">
+                <a:solidFill>
+                  <a:srgbClr val="0F2038"/>
+                </a:solidFill>
+                <a:latin typeface="Aptos"/>
+              </a:rPr>
+              <a:t>Mitigation plan</a:t>
+            </a:r>
+            <a:br/>
+            <a:r>
+              <a:rPr sz="1400" b="0">
+                <a:solidFill>
+                  <a:srgbClr val="0F2038"/>
+                </a:solidFill>
+                <a:latin typeface="Aptos"/>
+              </a:rPr>
+              <a:t>- Expand executive sponsor coverage for top accounts.</a:t>
+            </a:r>
+            <a:br/>
+            <a:r>
+              <a:rPr sz="1400" b="0">
+                <a:solidFill>
+                  <a:srgbClr val="0F2038"/>
+                </a:solidFill>
+                <a:latin typeface="Aptos"/>
+              </a:rPr>
+              <a:t>- Launch SMB onboarding redesign before end of Q2.</a:t>
+            </a:r>
+            <a:br/>
+            <a:r>
+              <a:rPr sz="1400" b="0">
+                <a:solidFill>
+                  <a:srgbClr val="0F2038"/>
+                </a:solidFill>
+                <a:latin typeface="Aptos"/>
+              </a:rPr>
+              <a:t>- Add usage-based cost guardrails to AI workloads.</a:t>
+            </a:r>
+            <a:br/>
+            <a:r>
+              <a:rPr sz="1400" b="0">
+                <a:solidFill>
+                  <a:srgbClr val="0F2038"/>
+                </a:solidFill>
+                <a:latin typeface="Aptos"/>
+              </a:rPr>
+              <a:t>- Pull forward two implementation hires if bookings convert.</a:t>
+            </a:r>
+          </a:p>
+        </p:txBody>
+      </p:sp>
+      <p:sp>
+        <p:nvSpPr>
+          <p:cNvPr id="9" name="TextBox 8"/>
+          <p:cNvSpPr txBox="1"/>
+          <p:nvPr/>
+        </p:nvSpPr>
+        <p:spPr>
+          <a:xfrm>
+            <a:off x="822960" y="4892040"/>
+            <a:ext cx="10058400" cy="438912"/>
+          </a:xfrm>
+          <a:prstGeom prst="rect">
+            <a:avLst/>
+          </a:prstGeom>
+          <a:noFill/>
+        </p:spPr>
+        <p:txBody>
+          <a:bodyPr wrap="square">
+            <a:spAutoFit/>
+          </a:bodyPr>
+          <a:lstStyle/>
+          <a:p>
+            <a:pPr algn="l"/>
+            <a:r>
+              <a:rPr sz="1600" b="1">
+                <a:solidFill>
+                  <a:srgbClr val="0057A4"/>
+                </a:solidFill>
+                <a:latin typeface="Aptos"/>
+              </a:rPr>
+              <a:t>Board discussion: Should management continue trading SMB growth for enterprise focus in Q2?</a:t>
+            </a:r>
+          </a:p>
+        </p:txBody>
+      </p:sp>
+      <p:sp>
+        <p:nvSpPr>
+          <p:cNvPr id="10" name="TextBox 9"/>
+          <p:cNvSpPr txBox="1"/>
+          <p:nvPr/>
+        </p:nvSpPr>
+        <p:spPr>
+          <a:xfrm>
+            <a:off x="502920" y="6473952"/>
+            <a:ext cx="6400800" cy="201168"/>
+          </a:xfrm>
+          <a:prstGeom prst="rect">
+            <a:avLst/>
+          </a:prstGeom>
+          <a:noFill/>
+        </p:spPr>
+        <p:txBody>
+          <a:bodyPr wrap="square">
+            <a:spAutoFit/>
+          </a:bodyPr>
+          <a:lstStyle/>
+          <a:p>
+            <a:pPr algn="l"/>
+            <a:r>
+              <a:rPr sz="700" b="0">
+                <a:solidFill>
+                  <a:srgbClr val="64748B"/>
+                </a:solidFill>
+                <a:latin typeface="Aptos"/>
+              </a:rPr>
+              <a:t>Acme Growth Co. | Board Review Template | Q1 2026</a:t>
+            </a:r>
+          </a:p>
+        </p:txBody>
+      </p:sp>
+      <p:sp>
+        <p:nvSpPr>
+          <p:cNvPr id="11" name="TextBox 10"/>
+          <p:cNvSpPr txBox="1"/>
+          <p:nvPr/>
+        </p:nvSpPr>
+        <p:spPr>
+          <a:xfrm>
+            <a:off x="8503920" y="6473952"/>
+            <a:ext cx="2926080" cy="201168"/>
+          </a:xfrm>
+          <a:prstGeom prst="rect">
+            <a:avLst/>
+          </a:prstGeom>
+          <a:noFill/>
+        </p:spPr>
+        <p:txBody>
+          <a:bodyPr wrap="square">
+            <a:spAutoFit/>
+          </a:bodyPr>
+          <a:lstStyle/>
+          <a:p>
+            <a:pPr algn="r"/>
+            <a:r>
+              <a:rPr sz="700" b="0">
+                <a:solidFill>
+                  <a:srgbClr val="64748B"/>
+                </a:solidFill>
+                <a:latin typeface="Aptos"/>
+              </a:rPr>
+              <a:t>For internal planning discussion only</a:t>
+            </a:r>
+          </a:p>
+        </p:txBody>
+      </p:sp>
+    </p:spTree>
+  </p:cSld>
+  <p:clrMapOvr>
+    <a:masterClrMapping/>
+  </p:clrMapOvr>
+</p:sld>
+</file>
+
+<file path=ppt/slides/slide6.xml><?xml version="1.0" encoding="utf-8"?>
+<p:sld xmlns:a="http://schemas.openxmlformats.org/drawingml/2006/main" xmlns:p="http://schemas.openxmlformats.org/presentationml/2006/main" xmlns:r="http://schemas.openxmlformats.org/officeDocument/2006/relationships">
+  <p:cSld>
+    <p:spTree>
+      <p:nvGrpSpPr>
+        <p:cNvPr id="1" name=""/>
+        <p:cNvGrpSpPr/>
+        <p:nvPr/>
+      </p:nvGrpSpPr>
+      <p:grpSpPr/>
+      <p:sp>
+        <p:nvSpPr>
+          <p:cNvPr id="2" name="Rectangle 1"/>
+          <p:cNvSpPr/>
+          <p:nvPr/>
+        </p:nvSpPr>
+        <p:spPr>
+          <a:xfrm>
+            <a:off x="0" y="0"/>
+            <a:ext cx="12191695" cy="164592"/>
+          </a:xfrm>
+          <a:prstGeom prst="rect">
+            <a:avLst/>
+          </a:prstGeom>
+          <a:solidFill>
+            <a:srgbClr val="0057A4"/>
+          </a:solidFill>
+          <a:ln>
+            <a:noFill/>
+          </a:ln>
+        </p:spPr>
+        <p:style>
+          <a:lnRef idx="1">
+            <a:schemeClr val="accent1"/>
+          </a:lnRef>
+          <a:fillRef idx="3">
+            <a:schemeClr val="accent1"/>
+          </a:fillRef>
+          <a:effectRef idx="2">
+            <a:schemeClr val="accent1"/>
+          </a:effectRef>
+          <a:fontRef idx="minor">
+            <a:schemeClr val="lt1"/>
+          </a:fontRef>
+        </p:style>
+        <p:txBody>
+          <a:bodyPr rtlCol="0" anchor="ctr"/>
+          <a:lstStyle/>
+          <a:p>
+            <a:pPr algn="ctr"/>
+          </a:p>
+        </p:txBody>
+      </p:sp>
+      <p:sp>
+        <p:nvSpPr>
+          <p:cNvPr id="3" name="TextBox 2"/>
+          <p:cNvSpPr txBox="1"/>
+          <p:nvPr/>
+        </p:nvSpPr>
+        <p:spPr>
+          <a:xfrm>
+            <a:off x="502920" y="256032"/>
+            <a:ext cx="3108960" cy="228600"/>
+          </a:xfrm>
+          <a:prstGeom prst="rect">
+            <a:avLst/>
+          </a:prstGeom>
+          <a:noFill/>
+        </p:spPr>
+        <p:txBody>
+          <a:bodyPr wrap="square">
+            <a:spAutoFit/>
+          </a:bodyPr>
+          <a:lstStyle/>
+          <a:p>
+            <a:pPr algn="l"/>
+            <a:r>
+              <a:rPr sz="700" b="1">
+                <a:solidFill>
+                  <a:srgbClr val="64748B"/>
+                </a:solidFill>
+                <a:latin typeface="Aptos"/>
+              </a:rPr>
+              <a:t>CONFIDENTIAL BUSINESS REVIEW</a:t>
+            </a:r>
+          </a:p>
+        </p:txBody>
+      </p:sp>
+      <p:sp>
+        <p:nvSpPr>
+          <p:cNvPr id="4" name="TextBox 3"/>
+          <p:cNvSpPr txBox="1"/>
+          <p:nvPr/>
+        </p:nvSpPr>
+        <p:spPr>
+          <a:xfrm>
+            <a:off x="502920" y="530352"/>
+            <a:ext cx="8046720" cy="438912"/>
+          </a:xfrm>
+          <a:prstGeom prst="rect">
+            <a:avLst/>
+          </a:prstGeom>
+          <a:noFill/>
+        </p:spPr>
+        <p:txBody>
+          <a:bodyPr wrap="square">
+            <a:spAutoFit/>
+          </a:bodyPr>
+          <a:lstStyle/>
+          <a:p>
+            <a:pPr algn="l"/>
+            <a:r>
+              <a:rPr sz="2300" b="1">
+                <a:solidFill>
+                  <a:srgbClr val="0F2038"/>
+                </a:solidFill>
+                <a:latin typeface="Aptos"/>
+              </a:rPr>
+              <a:t>Q2 priorities and decision requests</a:t>
+            </a:r>
+          </a:p>
+        </p:txBody>
+      </p:sp>
+      <p:sp>
+        <p:nvSpPr>
+          <p:cNvPr id="5" name="TextBox 4"/>
+          <p:cNvSpPr txBox="1"/>
+          <p:nvPr/>
+        </p:nvSpPr>
+        <p:spPr>
+          <a:xfrm>
+            <a:off x="10378440" y="393192"/>
+            <a:ext cx="1234440" cy="320040"/>
+          </a:xfrm>
+          <a:prstGeom prst="rect">
+            <a:avLst/>
+          </a:prstGeom>
+          <a:solidFill>
+            <a:srgbClr val="F58220"/>
+          </a:solidFill>
+          <a:ln>
+            <a:noFill/>
+          </a:ln>
+        </p:spPr>
+        <p:txBody>
+          <a:bodyPr wrap="square">
+            <a:spAutoFit/>
+          </a:bodyPr>
+          <a:lstStyle/>
+          <a:p>
+            <a:pPr algn="ctr"/>
+            <a:r>
+              <a:rPr sz="1000" b="1">
+                <a:solidFill>
+                  <a:srgbClr val="FFFFFF"/>
+                </a:solidFill>
+                <a:latin typeface="Aptos"/>
+              </a:rPr>
+              <a:t>Q1 2026</a:t>
+            </a:r>
+          </a:p>
+        </p:txBody>
+      </p:sp>
+      <p:sp>
+        <p:nvSpPr>
+          <p:cNvPr id="6" name="TextBox 5"/>
+          <p:cNvSpPr txBox="1"/>
+          <p:nvPr/>
+        </p:nvSpPr>
+        <p:spPr>
+          <a:xfrm>
+            <a:off x="685800" y="1234440"/>
+            <a:ext cx="4023360" cy="411480"/>
+          </a:xfrm>
+          <a:prstGeom prst="rect">
+            <a:avLst/>
+          </a:prstGeom>
+          <a:noFill/>
+        </p:spPr>
+        <p:txBody>
+          <a:bodyPr wrap="square">
+            <a:spAutoFit/>
+          </a:bodyPr>
+          <a:lstStyle/>
+          <a:p>
+            <a:pPr algn="l"/>
+            <a:r>
+              <a:rPr sz="1800" b="1">
+                <a:solidFill>
+                  <a:srgbClr val="0F2038"/>
+                </a:solidFill>
+                <a:latin typeface="Aptos"/>
+              </a:rPr>
+              <a:t>Q1-to-Q2 operating bridge</a:t>
+            </a:r>
+          </a:p>
+        </p:txBody>
+      </p:sp>
+      <p:sp>
+        <p:nvSpPr>
+          <p:cNvPr id="7" name="TextBox 6"/>
+          <p:cNvSpPr txBox="1"/>
+          <p:nvPr/>
+        </p:nvSpPr>
+        <p:spPr>
+          <a:xfrm>
+            <a:off x="822960" y="1828800"/>
+            <a:ext cx="4709160" cy="1920240"/>
+          </a:xfrm>
+          <a:prstGeom prst="rect">
+            <a:avLst/>
+          </a:prstGeom>
+          <a:noFill/>
+        </p:spPr>
+        <p:txBody>
+          <a:bodyPr wrap="square">
+            <a:spAutoFit/>
+          </a:bodyPr>
+          <a:lstStyle/>
+          <a:p>
+            <a:pPr algn="l"/>
+            <a:r>
+              <a:rPr sz="1600" b="0">
+                <a:solidFill>
+                  <a:srgbClr val="0F2038"/>
+                </a:solidFill>
+                <a:latin typeface="Aptos"/>
+              </a:rPr>
+              <a:t>1. Convert enterprise late-stage pipeline</a:t>
+            </a:r>
+            <a:br/>
+            <a:r>
+              <a:rPr sz="1600" b="0">
+                <a:solidFill>
+                  <a:srgbClr val="0F2038"/>
+                </a:solidFill>
+                <a:latin typeface="Aptos"/>
+              </a:rPr>
+              <a:t>2. Improve SMB onboarding and retention</a:t>
+            </a:r>
+            <a:br/>
+            <a:r>
+              <a:rPr sz="1600" b="0">
+                <a:solidFill>
+                  <a:srgbClr val="0F2038"/>
+                </a:solidFill>
+                <a:latin typeface="Aptos"/>
+              </a:rPr>
+              <a:t>3. Protect margin while scaling AI features</a:t>
+            </a:r>
+            <a:br/>
+            <a:r>
+              <a:rPr sz="1600" b="0">
+                <a:solidFill>
+                  <a:srgbClr val="0F2038"/>
+                </a:solidFill>
+                <a:latin typeface="Aptos"/>
+              </a:rPr>
+              <a:t>4. Maintain hiring discipline against revenue proof points</a:t>
+            </a:r>
+          </a:p>
+        </p:txBody>
+      </p:sp>
+      <p:sp>
+        <p:nvSpPr>
+          <p:cNvPr id="8" name="TextBox 7"/>
+          <p:cNvSpPr txBox="1"/>
+          <p:nvPr/>
+        </p:nvSpPr>
+        <p:spPr>
+          <a:xfrm>
+            <a:off x="6263640" y="1554480"/>
+            <a:ext cx="4846320" cy="1417320"/>
+          </a:xfrm>
+          <a:prstGeom prst="rect">
+            <a:avLst/>
+          </a:prstGeom>
+          <a:noFill/>
+        </p:spPr>
+        <p:txBody>
+          <a:bodyPr wrap="square">
+            <a:spAutoFit/>
+          </a:bodyPr>
+          <a:lstStyle/>
+          <a:p>
+            <a:pPr algn="l"/>
+            <a:r>
+              <a:rPr sz="1500" b="0">
+                <a:solidFill>
+                  <a:srgbClr val="0F2038"/>
+                </a:solidFill>
+                <a:latin typeface="Aptos"/>
+              </a:rPr>
+              <a:t>Q1 decision requests</a:t>
+            </a:r>
+            <a:br/>
+            <a:r>
+              <a:rPr sz="1500" b="0">
+                <a:solidFill>
+                  <a:srgbClr val="0F2038"/>
+                </a:solidFill>
+                <a:latin typeface="Aptos"/>
+              </a:rPr>
+              <a:t>- Approve $420K incremental enterprise GTM capacity.</a:t>
+            </a:r>
+            <a:br/>
+            <a:r>
+              <a:rPr sz="1500" b="0">
+                <a:solidFill>
+                  <a:srgbClr val="0F2038"/>
+                </a:solidFill>
+                <a:latin typeface="Aptos"/>
+              </a:rPr>
+              <a:t>- Hold Q2 brand spend until pipeline conversion improves.</a:t>
+            </a:r>
+            <a:br/>
+            <a:r>
+              <a:rPr sz="1500" b="0">
+                <a:solidFill>
+                  <a:srgbClr val="0F2038"/>
+                </a:solidFill>
+                <a:latin typeface="Aptos"/>
+              </a:rPr>
+              <a:t>- Confirm risk appetite for AI feature infrastructure cost.</a:t>
+            </a:r>
+          </a:p>
+        </p:txBody>
+      </p:sp>
+      <p:sp>
+        <p:nvSpPr>
+          <p:cNvPr id="9" name="TextBox 8"/>
+          <p:cNvSpPr txBox="1"/>
+          <p:nvPr/>
+        </p:nvSpPr>
+        <p:spPr>
+          <a:xfrm>
+            <a:off x="6263640" y="3749039"/>
+            <a:ext cx="4572000" cy="731520"/>
+          </a:xfrm>
+          <a:prstGeom prst="rect">
+            <a:avLst/>
+          </a:prstGeom>
+          <a:noFill/>
+        </p:spPr>
+        <p:txBody>
+          <a:bodyPr wrap="square">
+            <a:spAutoFit/>
+          </a:bodyPr>
+          <a:lstStyle/>
+          <a:p>
+            <a:pPr algn="l"/>
+            <a:r>
+              <a:rPr sz="1600" b="1">
+                <a:solidFill>
+                  <a:srgbClr val="0057A4"/>
+                </a:solidFill>
+                <a:latin typeface="Aptos"/>
+              </a:rPr>
+              <a:t>Expected Q2 board update: conversion quality, retention progress, and infrastructure cost envelope.</a:t>
+            </a:r>
+          </a:p>
+        </p:txBody>
+      </p:sp>
+      <p:sp>
+        <p:nvSpPr>
+          <p:cNvPr id="10" name="TextBox 9"/>
+          <p:cNvSpPr txBox="1"/>
+          <p:nvPr/>
+        </p:nvSpPr>
+        <p:spPr>
+          <a:xfrm>
+            <a:off x="502920" y="6473952"/>
+            <a:ext cx="6400800" cy="201168"/>
+          </a:xfrm>
+          <a:prstGeom prst="rect">
+            <a:avLst/>
+          </a:prstGeom>
+          <a:noFill/>
+        </p:spPr>
+        <p:txBody>
+          <a:bodyPr wrap="square">
+            <a:spAutoFit/>
+          </a:bodyPr>
+          <a:lstStyle/>
+          <a:p>
+            <a:pPr algn="l"/>
+            <a:r>
+              <a:rPr sz="700" b="0">
+                <a:solidFill>
+                  <a:srgbClr val="64748B"/>
+                </a:solidFill>
+                <a:latin typeface="Aptos"/>
+              </a:rPr>
+              <a:t>Acme Growth Co. | Board Review Template | Q1 2026</a:t>
+            </a:r>
+          </a:p>
+        </p:txBody>
+      </p:sp>
+      <p:sp>
+        <p:nvSpPr>
+          <p:cNvPr id="11" name="TextBox 10"/>
+          <p:cNvSpPr txBox="1"/>
+          <p:nvPr/>
+        </p:nvSpPr>
+        <p:spPr>
+          <a:xfrm>
+            <a:off x="8503920" y="6473952"/>
+            <a:ext cx="2926080" cy="201168"/>
+          </a:xfrm>
+          <a:prstGeom prst="rect">
+            <a:avLst/>
+          </a:prstGeom>
+          <a:noFill/>
+        </p:spPr>
+        <p:txBody>
+          <a:bodyPr wrap="square">
+            <a:spAutoFit/>
+          </a:bodyPr>
+          <a:lstStyle/>
+          <a:p>
+            <a:pPr algn="r"/>
+            <a:r>
+              <a:rPr sz="700" b="0">
+                <a:solidFill>
+                  <a:srgbClr val="64748B"/>
+                </a:solidFill>
+                <a:latin typeface="Aptos"/>
+              </a:rPr>
+              <a:t>For internal planning discussion only</a:t>
             </a:r>
           </a:p>
         </p:txBody>

</xml_diff>